<commit_message>
chore: add live demo URL to slides and optimize static hosting assets
</commit_message>
<xml_diff>
--- a/janus_presentation.pptx
+++ b/janus_presentation.pptx
@@ -3088,7 +3088,7 @@
     <p:bg>
       <p:bgPr>
         <a:solidFill>
-          <a:srgbClr val="090912"/>
+          <a:srgbClr val="060A15"/>
         </a:solidFill>
         <a:effectLst/>
       </p:bgPr>
@@ -3108,8 +3108,8 @@
         </p:nvSpPr>
         <p:spPr>
           <a:xfrm>
-            <a:off x="11094415" y="6492240"/>
-            <a:ext cx="914400" cy="274320"/>
+            <a:off x="8991295" y="6492240"/>
+            <a:ext cx="2926080" cy="274320"/>
           </a:xfrm>
           <a:prstGeom prst="rect">
             <a:avLst/>
@@ -3124,13 +3124,13 @@
           <a:p>
             <a:pPr algn="r"/>
             <a:r>
-              <a:rPr sz="1100" b="0" i="0">
-                <a:solidFill>
-                  <a:srgbClr val="C8C8D8"/>
-                </a:solidFill>
-                <a:latin typeface="Calibri"/>
-              </a:rPr>
-              <a:t>1 / 5</a:t>
+              <a:rPr sz="1000" b="0" i="0">
+                <a:solidFill>
+                  <a:srgbClr val="00E6BD"/>
+                </a:solidFill>
+                <a:latin typeface="Trebuchet MS"/>
+              </a:rPr>
+              <a:t>PHM MISSION LOG: SLIDE 1 OF 5</a:t>
             </a:r>
           </a:p>
         </p:txBody>
@@ -3150,7 +3150,7 @@
             <a:avLst/>
           </a:prstGeom>
           <a:solidFill>
-            <a:srgbClr val="A04EFF"/>
+            <a:srgbClr val="FF9D00"/>
           </a:solidFill>
           <a:ln>
             <a:noFill/>
@@ -3186,8 +3186,8 @@
         </p:nvSpPr>
         <p:spPr>
           <a:xfrm>
-            <a:off x="365760" y="201168"/>
-            <a:ext cx="7315200" cy="640080"/>
+            <a:off x="365760" y="164592"/>
+            <a:ext cx="9144000" cy="502920"/>
           </a:xfrm>
           <a:prstGeom prst="rect">
             <a:avLst/>
@@ -3202,13 +3202,13 @@
           <a:p>
             <a:pPr algn="l"/>
             <a:r>
-              <a:rPr sz="3000" b="1" i="0">
+              <a:rPr sz="2800" b="1" i="0">
                 <a:solidFill>
                   <a:srgbClr val="FFFFFF"/>
                 </a:solidFill>
-                <a:latin typeface="Calibri"/>
-              </a:rPr>
-              <a:t>LIGHT-DRIVEN JANUS PARTICLE SWARMS</a:t>
+                <a:latin typeface="Trebuchet MS"/>
+              </a:rPr>
+              <a:t>PROJECT HAIL MARY: THE ASTROPHAGE SWARM</a:t>
             </a:r>
           </a:p>
         </p:txBody>
@@ -3221,8 +3221,8 @@
         </p:nvSpPr>
         <p:spPr>
           <a:xfrm>
-            <a:off x="365760" y="868680"/>
-            <a:ext cx="7315200" cy="411480"/>
+            <a:off x="365760" y="658368"/>
+            <a:ext cx="9144000" cy="320040"/>
           </a:xfrm>
           <a:prstGeom prst="rect">
             <a:avLst/>
@@ -3237,33 +3237,68 @@
           <a:p>
             <a:pPr algn="l"/>
             <a:r>
-              <a:rPr sz="1700" b="0" i="1">
-                <a:solidFill>
-                  <a:srgbClr val="00D4FF"/>
-                </a:solidFill>
-                <a:latin typeface="Calibri"/>
-              </a:rPr>
-              <a:t>What are interesting patterns &amp; dynamics?</a:t>
-            </a:r>
-          </a:p>
-        </p:txBody>
-      </p:sp>
-      <p:sp>
-        <p:nvSpPr>
-          <p:cNvPr id="6" name="Rectangle 5"/>
+              <a:rPr sz="1600" b="0" i="1">
+                <a:solidFill>
+                  <a:srgbClr val="00E6BD"/>
+                </a:solidFill>
+                <a:latin typeface="Trebuchet MS"/>
+              </a:rPr>
+              <a:t>Emergent Light-Driven Swarms &amp; Collective Phototaxis in Space</a:t>
+            </a:r>
+          </a:p>
+        </p:txBody>
+      </p:sp>
+      <p:sp>
+        <p:nvSpPr>
+          <p:cNvPr id="6" name="TextBox 5"/>
+          <p:cNvSpPr txBox="1"/>
+          <p:nvPr/>
+        </p:nvSpPr>
+        <p:spPr>
+          <a:xfrm>
+            <a:off x="365760" y="987552"/>
+            <a:ext cx="9144000" cy="320040"/>
+          </a:xfrm>
+          <a:prstGeom prst="rect">
+            <a:avLst/>
+          </a:prstGeom>
+          <a:noFill/>
+        </p:spPr>
+        <p:txBody>
+          <a:bodyPr wrap="square">
+            <a:spAutoFit/>
+          </a:bodyPr>
+          <a:lstStyle/>
+          <a:p>
+            <a:pPr algn="l"/>
+            <a:r>
+              <a:rPr sz="1400" b="1" i="0">
+                <a:solidFill>
+                  <a:srgbClr val="FF9D00"/>
+                </a:solidFill>
+                <a:latin typeface="Trebuchet MS"/>
+              </a:rPr>
+              <a:t>Demo at https://prs-016.github.io/active-matter-microbialspacesims/</a:t>
+            </a:r>
+          </a:p>
+        </p:txBody>
+      </p:sp>
+      <p:sp>
+        <p:nvSpPr>
+          <p:cNvPr id="7" name="Rectangle 6"/>
           <p:cNvSpPr/>
           <p:nvPr/>
         </p:nvSpPr>
         <p:spPr>
           <a:xfrm>
-            <a:off x="365760" y="1325880"/>
-            <a:ext cx="11430000" cy="38100"/>
+            <a:off x="365760" y="1353312"/>
+            <a:ext cx="11430000" cy="25400"/>
           </a:xfrm>
           <a:prstGeom prst="rect">
             <a:avLst/>
           </a:prstGeom>
           <a:solidFill>
-            <a:srgbClr val="A04EFF"/>
+            <a:srgbClr val="FF9D00"/>
           </a:solidFill>
           <a:ln>
             <a:noFill/>
@@ -3293,24 +3328,24 @@
       </p:sp>
       <p:sp>
         <p:nvSpPr>
-          <p:cNvPr id="7" name="Rounded Rectangle 6"/>
+          <p:cNvPr id="8" name="Rounded Rectangle 7"/>
           <p:cNvSpPr/>
           <p:nvPr/>
         </p:nvSpPr>
         <p:spPr>
           <a:xfrm>
-            <a:off x="320040" y="1463040"/>
-            <a:ext cx="5394960" cy="5074920"/>
+            <a:off x="320040" y="1444752"/>
+            <a:ext cx="5486400" cy="5074920"/>
           </a:xfrm>
           <a:prstGeom prst="roundRect">
             <a:avLst/>
           </a:prstGeom>
           <a:solidFill>
-            <a:srgbClr val="16162A"/>
+            <a:srgbClr val="111726"/>
           </a:solidFill>
           <a:ln w="19050">
             <a:solidFill>
-              <a:srgbClr val="A04EFF"/>
+              <a:srgbClr val="FF9D00"/>
             </a:solidFill>
           </a:ln>
         </p:spPr>
@@ -3338,7 +3373,7 @@
       </p:sp>
       <p:pic>
         <p:nvPicPr>
-          <p:cNvPr id="8" name="Picture 7" descr="demo_snapshot.png"/>
+          <p:cNvPr id="9" name="Picture 8" descr="demo_snapshot.png"/>
           <p:cNvPicPr>
             <a:picLocks noChangeAspect="1"/>
           </p:cNvPicPr>
@@ -3352,8 +3387,8 @@
         </p:blipFill>
         <p:spPr>
           <a:xfrm>
-            <a:off x="411480" y="1554480"/>
-            <a:ext cx="5212080" cy="4892040"/>
+            <a:off x="411480" y="1536192"/>
+            <a:ext cx="5303520" cy="4892040"/>
           </a:xfrm>
           <a:prstGeom prst="rect">
             <a:avLst/>
@@ -3362,24 +3397,24 @@
       </p:pic>
       <p:sp>
         <p:nvSpPr>
-          <p:cNvPr id="9" name="Rounded Rectangle 8"/>
+          <p:cNvPr id="10" name="Rounded Rectangle 9"/>
           <p:cNvSpPr/>
           <p:nvPr/>
         </p:nvSpPr>
         <p:spPr>
           <a:xfrm>
-            <a:off x="5989320" y="1463040"/>
-            <a:ext cx="5897880" cy="5074920"/>
+            <a:off x="6035040" y="1444752"/>
+            <a:ext cx="5852160" cy="5074920"/>
           </a:xfrm>
           <a:prstGeom prst="roundRect">
             <a:avLst/>
           </a:prstGeom>
           <a:solidFill>
-            <a:srgbClr val="16162A"/>
+            <a:srgbClr val="111726"/>
           </a:solidFill>
           <a:ln w="19050">
             <a:solidFill>
-              <a:srgbClr val="00D4FF"/>
+              <a:srgbClr val="00E6BD"/>
             </a:solidFill>
           </a:ln>
         </p:spPr>
@@ -3407,13 +3442,13 @@
       </p:sp>
       <p:sp>
         <p:nvSpPr>
-          <p:cNvPr id="10" name="TextBox 9"/>
+          <p:cNvPr id="11" name="TextBox 10"/>
           <p:cNvSpPr txBox="1"/>
           <p:nvPr/>
         </p:nvSpPr>
         <p:spPr>
           <a:xfrm>
-            <a:off x="6172200" y="1572768"/>
+            <a:off x="6217920" y="1572768"/>
             <a:ext cx="5486400" cy="457200"/>
           </a:xfrm>
           <a:prstGeom prst="rect">
@@ -3431,31 +3466,31 @@
             <a:r>
               <a:rPr sz="1700" b="1" i="0">
                 <a:solidFill>
-                  <a:srgbClr val="00D4FF"/>
-                </a:solidFill>
-                <a:latin typeface="Calibri"/>
-              </a:rPr>
-              <a:t>🔬  Key Observations</a:t>
-            </a:r>
-          </a:p>
-        </p:txBody>
-      </p:sp>
-      <p:sp>
-        <p:nvSpPr>
-          <p:cNvPr id="11" name="Rectangle 10"/>
+                  <a:srgbClr val="00E6BD"/>
+                </a:solidFill>
+                <a:latin typeface="Trebuchet MS"/>
+              </a:rPr>
+              <a:t>🛰️  Mission Observations</a:t>
+            </a:r>
+          </a:p>
+        </p:txBody>
+      </p:sp>
+      <p:sp>
+        <p:nvSpPr>
+          <p:cNvPr id="12" name="Rectangle 11"/>
           <p:cNvSpPr/>
           <p:nvPr/>
         </p:nvSpPr>
         <p:spPr>
           <a:xfrm>
-            <a:off x="6172200" y="2029968"/>
-            <a:ext cx="5486400" cy="25400"/>
+            <a:off x="6217920" y="2011680"/>
+            <a:ext cx="5486400" cy="19050"/>
           </a:xfrm>
           <a:prstGeom prst="rect">
             <a:avLst/>
           </a:prstGeom>
           <a:solidFill>
-            <a:srgbClr val="00D4FF"/>
+            <a:srgbClr val="00E6BD"/>
           </a:solidFill>
           <a:ln>
             <a:noFill/>
@@ -3485,14 +3520,14 @@
       </p:sp>
       <p:sp>
         <p:nvSpPr>
-          <p:cNvPr id="12" name="TextBox 11"/>
+          <p:cNvPr id="13" name="TextBox 12"/>
           <p:cNvSpPr txBox="1"/>
           <p:nvPr/>
         </p:nvSpPr>
         <p:spPr>
           <a:xfrm>
-            <a:off x="6172200" y="2084831"/>
-            <a:ext cx="5577840" cy="4297680"/>
+            <a:off x="6217920" y="2084831"/>
+            <a:ext cx="5486400" cy="4297680"/>
           </a:xfrm>
           <a:prstGeom prst="rect">
             <a:avLst/>
@@ -3507,47 +3542,47 @@
           <a:p>
             <a:pPr algn="l">
               <a:spcAft>
-                <a:spcPts val="200"/>
+                <a:spcPts val="150"/>
               </a:spcAft>
             </a:pPr>
             <a:r>
-              <a:rPr sz="1500" b="1" i="0">
+              <a:rPr sz="1400" b="1" i="0">
                 <a:solidFill>
                   <a:srgbClr val="FFFFFF"/>
                 </a:solidFill>
-                <a:latin typeface="Calibri"/>
-              </a:rPr>
-              <a:t>⚡  Self-Propulsion via Photophoresis</a:t>
+                <a:latin typeface="Trebuchet MS"/>
+              </a:rPr>
+              <a:t>🔆  Sun-Powered Thrust (Photophoresis)</a:t>
             </a:r>
           </a:p>
           <a:p>
             <a:pPr algn="l">
               <a:spcAft>
-                <a:spcPts val="200"/>
+                <a:spcPts val="150"/>
               </a:spcAft>
             </a:pPr>
             <a:r>
-              <a:rPr sz="1300" b="0" i="1">
-                <a:solidFill>
-                  <a:srgbClr val="C8C8D8"/>
-                </a:solidFill>
-                <a:latin typeface="Calibri"/>
-              </a:rPr>
-              <a:t>    Metal cap absorbs light → asymmetric heating → thrust</a:t>
+              <a:rPr sz="1200" b="0" i="1">
+                <a:solidFill>
+                  <a:srgbClr val="BCC4D0"/>
+                </a:solidFill>
+                <a:latin typeface="Trebuchet MS"/>
+              </a:rPr>
+              <a:t>    Cap-specific radiation absorption creates temperature differences, driving thrust.</a:t>
             </a:r>
           </a:p>
           <a:p>
             <a:pPr algn="l">
               <a:spcAft>
-                <a:spcPts val="200"/>
+                <a:spcPts val="150"/>
               </a:spcAft>
             </a:pPr>
             <a:r>
-              <a:rPr sz="800" b="0" i="0">
+              <a:rPr sz="600" b="0" i="0">
                 <a:solidFill>
                   <a:srgbClr val="FFFFFF"/>
                 </a:solidFill>
-                <a:latin typeface="Calibri"/>
+                <a:latin typeface="Trebuchet MS"/>
               </a:rPr>
               <a:t/>
             </a:r>
@@ -3555,47 +3590,47 @@
           <a:p>
             <a:pPr algn="l">
               <a:spcAft>
-                <a:spcPts val="200"/>
+                <a:spcPts val="150"/>
               </a:spcAft>
             </a:pPr>
             <a:r>
-              <a:rPr sz="1500" b="1" i="0">
+              <a:rPr sz="1400" b="1" i="0">
                 <a:solidFill>
                   <a:srgbClr val="FFFFFF"/>
                 </a:solidFill>
-                <a:latin typeface="Calibri"/>
-              </a:rPr>
-              <a:t>🌀  Collective Flocking (Vicsek-like)</a:t>
+                <a:latin typeface="Trebuchet MS"/>
+              </a:rPr>
+              <a:t>🌀  Astrophage Collective Flocking</a:t>
             </a:r>
           </a:p>
           <a:p>
             <a:pPr algn="l">
               <a:spcAft>
-                <a:spcPts val="200"/>
+                <a:spcPts val="150"/>
               </a:spcAft>
             </a:pPr>
             <a:r>
-              <a:rPr sz="1300" b="0" i="1">
-                <a:solidFill>
-                  <a:srgbClr val="C8C8D8"/>
-                </a:solidFill>
-                <a:latin typeface="Calibri"/>
-              </a:rPr>
-              <a:t>    Thermal radiation couples neighbors: local alignment torques emerge spontaneously</a:t>
+              <a:rPr sz="1200" b="0" i="1">
+                <a:solidFill>
+                  <a:srgbClr val="BCC4D0"/>
+                </a:solidFill>
+                <a:latin typeface="Trebuchet MS"/>
+              </a:rPr>
+              <a:t>    Thermoosmotic interactions couple neighbors, triggering spontaneous group alignment.</a:t>
             </a:r>
           </a:p>
           <a:p>
             <a:pPr algn="l">
               <a:spcAft>
-                <a:spcPts val="200"/>
+                <a:spcPts val="150"/>
               </a:spcAft>
             </a:pPr>
             <a:r>
-              <a:rPr sz="800" b="0" i="0">
+              <a:rPr sz="600" b="0" i="0">
                 <a:solidFill>
                   <a:srgbClr val="FFFFFF"/>
                 </a:solidFill>
-                <a:latin typeface="Calibri"/>
+                <a:latin typeface="Trebuchet MS"/>
               </a:rPr>
               <a:t/>
             </a:r>
@@ -3603,47 +3638,47 @@
           <a:p>
             <a:pPr algn="l">
               <a:spcAft>
-                <a:spcPts val="200"/>
+                <a:spcPts val="150"/>
               </a:spcAft>
             </a:pPr>
             <a:r>
-              <a:rPr sz="1500" b="1" i="0">
+              <a:rPr sz="1400" b="1" i="0">
                 <a:solidFill>
                   <a:srgbClr val="FFFFFF"/>
                 </a:solidFill>
-                <a:latin typeface="Calibri"/>
-              </a:rPr>
-              <a:t>🔆  Speed Modulation by Local Light</a:t>
+                <a:latin typeface="Trebuchet MS"/>
+              </a:rPr>
+              <a:t>🎯  Solar Corona Targeting</a:t>
             </a:r>
           </a:p>
           <a:p>
             <a:pPr algn="l">
               <a:spcAft>
-                <a:spcPts val="200"/>
+                <a:spcPts val="150"/>
               </a:spcAft>
             </a:pPr>
             <a:r>
-              <a:rPr sz="1300" b="0" i="1">
-                <a:solidFill>
-                  <a:srgbClr val="C8C8D8"/>
-                </a:solidFill>
-                <a:latin typeface="Calibri"/>
-              </a:rPr>
-              <a:t>    v₀(i) = v_max · min(1, I_local / I_ref)  →  bright = fast, shadow = stalled</a:t>
+              <a:rPr sz="1200" b="0" i="1">
+                <a:solidFill>
+                  <a:srgbClr val="BCC4D0"/>
+                </a:solidFill>
+                <a:latin typeface="Trebuchet MS"/>
+              </a:rPr>
+              <a:t>    Individual phototactic steering guides the swarm directly to high-intensity targets.</a:t>
             </a:r>
           </a:p>
           <a:p>
             <a:pPr algn="l">
               <a:spcAft>
-                <a:spcPts val="200"/>
+                <a:spcPts val="150"/>
               </a:spcAft>
             </a:pPr>
             <a:r>
-              <a:rPr sz="800" b="0" i="0">
+              <a:rPr sz="600" b="0" i="0">
                 <a:solidFill>
                   <a:srgbClr val="FFFFFF"/>
                 </a:solidFill>
-                <a:latin typeface="Calibri"/>
+                <a:latin typeface="Trebuchet MS"/>
               </a:rPr>
               <a:t/>
             </a:r>
@@ -3651,81 +3686,33 @@
           <a:p>
             <a:pPr algn="l">
               <a:spcAft>
-                <a:spcPts val="200"/>
+                <a:spcPts val="150"/>
               </a:spcAft>
             </a:pPr>
             <a:r>
-              <a:rPr sz="1500" b="1" i="0">
+              <a:rPr sz="1400" b="1" i="0">
                 <a:solidFill>
                   <a:srgbClr val="FFFFFF"/>
                 </a:solidFill>
-                <a:latin typeface="Calibri"/>
-              </a:rPr>
-              <a:t>🎯  Emergent Target Seeking (Phototaxis)</a:t>
+                <a:latin typeface="Trebuchet MS"/>
+              </a:rPr>
+              <a:t>🌊  Chiral Symmetry Breaking (Circle Swimmers)</a:t>
             </a:r>
           </a:p>
           <a:p>
             <a:pPr algn="l">
               <a:spcAft>
-                <a:spcPts val="200"/>
+                <a:spcPts val="150"/>
               </a:spcAft>
             </a:pPr>
             <a:r>
-              <a:rPr sz="1300" b="0" i="1">
-                <a:solidFill>
-                  <a:srgbClr val="C8C8D8"/>
-                </a:solidFill>
-                <a:latin typeface="Calibri"/>
-              </a:rPr>
-              <a:t>    Without programming any global map, swarm steers toward a delivery zone</a:t>
-            </a:r>
-          </a:p>
-          <a:p>
-            <a:pPr algn="l">
-              <a:spcAft>
-                <a:spcPts val="200"/>
-              </a:spcAft>
-            </a:pPr>
-            <a:r>
-              <a:rPr sz="800" b="0" i="0">
-                <a:solidFill>
-                  <a:srgbClr val="FFFFFF"/>
-                </a:solidFill>
-                <a:latin typeface="Calibri"/>
-              </a:rPr>
-              <a:t/>
-            </a:r>
-          </a:p>
-          <a:p>
-            <a:pPr algn="l">
-              <a:spcAft>
-                <a:spcPts val="200"/>
-              </a:spcAft>
-            </a:pPr>
-            <a:r>
-              <a:rPr sz="1500" b="1" i="0">
-                <a:solidFill>
-                  <a:srgbClr val="FFFFFF"/>
-                </a:solidFill>
-                <a:latin typeface="Calibri"/>
-              </a:rPr>
-              <a:t>🌊  Chirality → Circle Swimmers</a:t>
-            </a:r>
-          </a:p>
-          <a:p>
-            <a:pPr algn="l">
-              <a:spcAft>
-                <a:spcPts val="200"/>
-              </a:spcAft>
-            </a:pPr>
-            <a:r>
-              <a:rPr sz="1300" b="0" i="1">
-                <a:solidFill>
-                  <a:srgbClr val="C8C8D8"/>
-                </a:solidFill>
-                <a:latin typeface="Calibri"/>
-              </a:rPr>
-              <a:t>    Adding turning rate ω breaks symmetry: epitrochoidal orbits appear</a:t>
+              <a:rPr sz="1200" b="0" i="1">
+                <a:solidFill>
+                  <a:srgbClr val="BCC4D0"/>
+                </a:solidFill>
+                <a:latin typeface="Trebuchet MS"/>
+              </a:rPr>
+              <a:t>    Asymmetric particle caps yield internal torque, converting straight paths into orbits.</a:t>
             </a:r>
           </a:p>
         </p:txBody>
@@ -3744,7 +3731,7 @@
     <p:bg>
       <p:bgPr>
         <a:solidFill>
-          <a:srgbClr val="090912"/>
+          <a:srgbClr val="060A15"/>
         </a:solidFill>
         <a:effectLst/>
       </p:bgPr>
@@ -3764,8 +3751,8 @@
         </p:nvSpPr>
         <p:spPr>
           <a:xfrm>
-            <a:off x="11094415" y="6492240"/>
-            <a:ext cx="914400" cy="274320"/>
+            <a:off x="8991295" y="6492240"/>
+            <a:ext cx="2926080" cy="274320"/>
           </a:xfrm>
           <a:prstGeom prst="rect">
             <a:avLst/>
@@ -3780,13 +3767,13 @@
           <a:p>
             <a:pPr algn="r"/>
             <a:r>
-              <a:rPr sz="1100" b="0" i="0">
-                <a:solidFill>
-                  <a:srgbClr val="C8C8D8"/>
-                </a:solidFill>
-                <a:latin typeface="Calibri"/>
-              </a:rPr>
-              <a:t>2 / 5</a:t>
+              <a:rPr sz="1000" b="0" i="0">
+                <a:solidFill>
+                  <a:srgbClr val="00E6BD"/>
+                </a:solidFill>
+                <a:latin typeface="Trebuchet MS"/>
+              </a:rPr>
+              <a:t>PHM MISSION LOG: SLIDE 2 OF 5</a:t>
             </a:r>
           </a:p>
         </p:txBody>
@@ -3806,7 +3793,7 @@
             <a:avLst/>
           </a:prstGeom>
           <a:solidFill>
-            <a:srgbClr val="00D4FF"/>
+            <a:srgbClr val="00E6BD"/>
           </a:solidFill>
           <a:ln>
             <a:noFill/>
@@ -3843,7 +3830,7 @@
         <p:spPr>
           <a:xfrm>
             <a:off x="365760" y="201168"/>
-            <a:ext cx="8229600" cy="594360"/>
+            <a:ext cx="9144000" cy="594360"/>
           </a:xfrm>
           <a:prstGeom prst="rect">
             <a:avLst/>
@@ -3858,13 +3845,13 @@
           <a:p>
             <a:pPr algn="l"/>
             <a:r>
-              <a:rPr sz="3000" b="1" i="0">
+              <a:rPr sz="2800" b="1" i="0">
                 <a:solidFill>
                   <a:srgbClr val="FFFFFF"/>
                 </a:solidFill>
-                <a:latin typeface="Calibri"/>
-              </a:rPr>
-              <a:t>THE PJPS MODEL</a:t>
+                <a:latin typeface="Trebuchet MS"/>
+              </a:rPr>
+              <a:t>ASTROPHAGE MATH: THE 3D/2D LANGEVIN MODEL</a:t>
             </a:r>
           </a:p>
         </p:txBody>
@@ -3877,8 +3864,8 @@
         </p:nvSpPr>
         <p:spPr>
           <a:xfrm>
-            <a:off x="365760" y="822960"/>
-            <a:ext cx="8229600" cy="365760"/>
+            <a:off x="365760" y="804672"/>
+            <a:ext cx="9144000" cy="365760"/>
           </a:xfrm>
           <a:prstGeom prst="rect">
             <a:avLst/>
@@ -3895,11 +3882,11 @@
             <a:r>
               <a:rPr sz="1600" b="0" i="1">
                 <a:solidFill>
-                  <a:srgbClr val="00D4FF"/>
-                </a:solidFill>
-                <a:latin typeface="Calibri"/>
-              </a:rPr>
-              <a:t>Photophoretic Janus Particle Swarm — equations &amp; visuals</a:t>
+                  <a:srgbClr val="00E6BD"/>
+                </a:solidFill>
+                <a:latin typeface="Trebuchet MS"/>
+              </a:rPr>
+              <a:t>Coupled active-matter equations governing phototactic swarm mechanics</a:t>
             </a:r>
           </a:p>
         </p:txBody>
@@ -3912,14 +3899,14 @@
         </p:nvSpPr>
         <p:spPr>
           <a:xfrm>
-            <a:off x="365760" y="1261872"/>
-            <a:ext cx="11430000" cy="38100"/>
+            <a:off x="365760" y="1243584"/>
+            <a:ext cx="11430000" cy="25400"/>
           </a:xfrm>
           <a:prstGeom prst="rect">
             <a:avLst/>
           </a:prstGeom>
           <a:solidFill>
-            <a:srgbClr val="00D4FF"/>
+            <a:srgbClr val="00E6BD"/>
           </a:solidFill>
           <a:ln>
             <a:noFill/>
@@ -3956,17 +3943,17 @@
         <p:spPr>
           <a:xfrm>
             <a:off x="320040" y="1371600"/>
-            <a:ext cx="6035040" cy="5166360"/>
+            <a:ext cx="6126480" cy="5166360"/>
           </a:xfrm>
           <a:prstGeom prst="roundRect">
             <a:avLst/>
           </a:prstGeom>
           <a:solidFill>
-            <a:srgbClr val="16162A"/>
+            <a:srgbClr val="111726"/>
           </a:solidFill>
           <a:ln w="19050">
             <a:solidFill>
-              <a:srgbClr val="00D4FF"/>
+              <a:srgbClr val="00E6BD"/>
             </a:solidFill>
           </a:ln>
         </p:spPr>
@@ -4001,7 +3988,7 @@
         <p:spPr>
           <a:xfrm>
             <a:off x="502920" y="1481328"/>
-            <a:ext cx="5715000" cy="4937760"/>
+            <a:ext cx="5760720" cy="4937760"/>
           </a:xfrm>
           <a:prstGeom prst="rect">
             <a:avLst/>
@@ -4016,63 +4003,63 @@
           <a:p>
             <a:pPr algn="l">
               <a:spcAft>
-                <a:spcPts val="100"/>
+                <a:spcPts val="120"/>
               </a:spcAft>
             </a:pPr>
             <a:r>
-              <a:rPr sz="1500" b="1" i="0">
-                <a:solidFill>
-                  <a:srgbClr val="00D4FF"/>
-                </a:solidFill>
-                <a:latin typeface="Calibri"/>
-              </a:rPr>
-              <a:t>📐  State Variables</a:t>
+              <a:rPr sz="1400" b="1" i="0">
+                <a:solidFill>
+                  <a:srgbClr val="00E6BD"/>
+                </a:solidFill>
+                <a:latin typeface="Trebuchet MS"/>
+              </a:rPr>
+              <a:t>📐  Model Coordinates</a:t>
             </a:r>
           </a:p>
           <a:p>
             <a:pPr algn="l">
               <a:spcAft>
-                <a:spcPts val="100"/>
+                <a:spcPts val="120"/>
               </a:spcAft>
             </a:pPr>
             <a:r>
-              <a:rPr sz="1300" b="0" i="0">
-                <a:solidFill>
-                  <a:srgbClr val="C8C8D8"/>
-                </a:solidFill>
-                <a:latin typeface="Calibri"/>
-              </a:rPr>
-              <a:t>    N particles in 2D box L×L</a:t>
+              <a:rPr sz="1200" b="0" i="0">
+                <a:solidFill>
+                  <a:srgbClr val="BCC4D0"/>
+                </a:solidFill>
+                <a:latin typeface="Trebuchet MS"/>
+              </a:rPr>
+              <a:t>    N active particles inside a periodic box L×L.</a:t>
             </a:r>
           </a:p>
           <a:p>
             <a:pPr algn="l">
               <a:spcAft>
-                <a:spcPts val="100"/>
+                <a:spcPts val="120"/>
               </a:spcAft>
             </a:pPr>
             <a:r>
-              <a:rPr sz="1300" b="0" i="1">
+              <a:rPr sz="1200" b="0" i="1">
                 <a:solidFill>
                   <a:srgbClr val="FFFFFF"/>
                 </a:solidFill>
-                <a:latin typeface="Calibri"/>
-              </a:rPr>
-              <a:t>    Position rᵢ = (xᵢ, yᵢ)   |   Orientation θᵢ ∈ [0, 2π)</a:t>
+                <a:latin typeface="Trebuchet MS"/>
+              </a:rPr>
+              <a:t>    State: Position rᵢ = (xᵢ, yᵢ)   |   Heading vector e_θi = (cos θᵢ, sin θᵢ)</a:t>
             </a:r>
           </a:p>
           <a:p>
             <a:pPr algn="l">
               <a:spcAft>
-                <a:spcPts val="100"/>
+                <a:spcPts val="120"/>
               </a:spcAft>
             </a:pPr>
             <a:r>
-              <a:rPr sz="700" b="0" i="0">
+              <a:rPr sz="500" b="0" i="0">
                 <a:solidFill>
                   <a:srgbClr val="FFFFFF"/>
                 </a:solidFill>
-                <a:latin typeface="Calibri"/>
+                <a:latin typeface="Trebuchet MS"/>
               </a:rPr>
               <a:t/>
             </a:r>
@@ -4080,111 +4067,111 @@
           <a:p>
             <a:pPr algn="l">
               <a:spcAft>
-                <a:spcPts val="100"/>
+                <a:spcPts val="120"/>
               </a:spcAft>
             </a:pPr>
             <a:r>
-              <a:rPr sz="1500" b="1" i="0">
-                <a:solidFill>
-                  <a:srgbClr val="A04EFF"/>
-                </a:solidFill>
-                <a:latin typeface="Calibri"/>
-              </a:rPr>
-              <a:t>🔄  Full Orientation Update  (Δt step)</a:t>
+              <a:rPr sz="1400" b="1" i="0">
+                <a:solidFill>
+                  <a:srgbClr val="FF9D00"/>
+                </a:solidFill>
+                <a:latin typeface="Trebuchet MS"/>
+              </a:rPr>
+              <a:t>🔄  Swarm Orientation Langevin Dynamics</a:t>
             </a:r>
           </a:p>
           <a:p>
             <a:pPr algn="l">
               <a:spcAft>
-                <a:spcPts val="100"/>
+                <a:spcPts val="120"/>
               </a:spcAft>
             </a:pPr>
             <a:r>
-              <a:rPr sz="1300" b="0" i="0">
-                <a:solidFill>
-                  <a:srgbClr val="C8C8D8"/>
-                </a:solidFill>
-                <a:latin typeface="Calibri"/>
-              </a:rPr>
-              <a:t>    θᵢ(t+dt) = θᵢ</a:t>
+              <a:rPr sz="1200" b="0" i="0">
+                <a:solidFill>
+                  <a:srgbClr val="BCC4D0"/>
+                </a:solidFill>
+                <a:latin typeface="Trebuchet MS"/>
+              </a:rPr>
+              <a:t>    θᵢ(t+dt) = θᵢ(t)</a:t>
             </a:r>
           </a:p>
           <a:p>
             <a:pPr algn="l">
               <a:spcAft>
-                <a:spcPts val="100"/>
+                <a:spcPts val="120"/>
               </a:spcAft>
             </a:pPr>
             <a:r>
-              <a:rPr sz="1300" b="0" i="1">
-                <a:solidFill>
-                  <a:srgbClr val="FFD700"/>
-                </a:solidFill>
-                <a:latin typeface="Calibri"/>
-              </a:rPr>
-              <a:t>         + J · sin(φ_align − θᵢ) · dt    [alignment]</a:t>
+              <a:rPr sz="1200" b="0" i="1">
+                <a:solidFill>
+                  <a:srgbClr val="FF9D00"/>
+                </a:solidFill>
+                <a:latin typeface="Trebuchet MS"/>
+              </a:rPr>
+              <a:t>         + J · sin(φ_align − θᵢ) · dt       [Vicsek Alignment]</a:t>
             </a:r>
           </a:p>
           <a:p>
             <a:pPr algn="l">
               <a:spcAft>
-                <a:spcPts val="100"/>
+                <a:spcPts val="120"/>
               </a:spcAft>
             </a:pPr>
             <a:r>
-              <a:rPr sz="1300" b="0" i="1">
-                <a:solidFill>
-                  <a:srgbClr val="00D4FF"/>
-                </a:solidFill>
-                <a:latin typeface="Calibri"/>
-              </a:rPr>
-              <a:t>         + α · sin(φ_target − θᵢ) · dt   [phototaxis]</a:t>
+              <a:rPr sz="1200" b="0" i="1">
+                <a:solidFill>
+                  <a:srgbClr val="00E6BD"/>
+                </a:solidFill>
+                <a:latin typeface="Trebuchet MS"/>
+              </a:rPr>
+              <a:t>         + α · sin(φ_target − θᵢ) · dt      [Solar Phototaxis]</a:t>
             </a:r>
           </a:p>
           <a:p>
             <a:pPr algn="l">
               <a:spcAft>
-                <a:spcPts val="100"/>
+                <a:spcPts val="120"/>
               </a:spcAft>
             </a:pPr>
             <a:r>
-              <a:rPr sz="1300" b="0" i="1">
-                <a:solidFill>
-                  <a:srgbClr val="FF6B6B"/>
-                </a:solidFill>
-                <a:latin typeface="Calibri"/>
-              </a:rPr>
-              <a:t>         + κ_B · sin(θ_B − θᵢ) · dt      [magnetic]</a:t>
+              <a:rPr sz="1200" b="0" i="1">
+                <a:solidFill>
+                  <a:srgbClr val="FF4B4B"/>
+                </a:solidFill>
+                <a:latin typeface="Trebuchet MS"/>
+              </a:rPr>
+              <a:t>         + κ_B · sin(θ_B − θᵢ) · dt         [Magnetic Gradients]</a:t>
             </a:r>
           </a:p>
           <a:p>
             <a:pPr algn="l">
               <a:spcAft>
-                <a:spcPts val="100"/>
+                <a:spcPts val="120"/>
               </a:spcAft>
             </a:pPr>
             <a:r>
-              <a:rPr sz="1300" b="0" i="1">
-                <a:solidFill>
-                  <a:srgbClr val="C8C8D8"/>
-                </a:solidFill>
-                <a:latin typeface="Calibri"/>
-              </a:rPr>
-              <a:t>         + η · ξᵢ · √dt                  [noise]</a:t>
+              <a:rPr sz="1200" b="0" i="1">
+                <a:solidFill>
+                  <a:srgbClr val="BCC4D0"/>
+                </a:solidFill>
+                <a:latin typeface="Trebuchet MS"/>
+              </a:rPr>
+              <a:t>         + η · ξᵢ · √dt                     [Rotational Noise (Dr)]</a:t>
             </a:r>
           </a:p>
           <a:p>
             <a:pPr algn="l">
               <a:spcAft>
-                <a:spcPts val="100"/>
+                <a:spcPts val="120"/>
               </a:spcAft>
             </a:pPr>
             <a:r>
-              <a:rPr sz="700" b="0" i="0">
+              <a:rPr sz="500" b="0" i="0">
                 <a:solidFill>
                   <a:srgbClr val="FFFFFF"/>
                 </a:solidFill>
-                <a:latin typeface="Calibri"/>
+                <a:latin typeface="Trebuchet MS"/>
               </a:rPr>
               <a:t/>
             </a:r>
@@ -4192,161 +4179,145 @@
           <a:p>
             <a:pPr algn="l">
               <a:spcAft>
-                <a:spcPts val="100"/>
+                <a:spcPts val="120"/>
               </a:spcAft>
             </a:pPr>
             <a:r>
-              <a:rPr sz="1500" b="1" i="0">
-                <a:solidFill>
-                  <a:srgbClr val="A04EFF"/>
-                </a:solidFill>
-                <a:latin typeface="Calibri"/>
-              </a:rPr>
-              <a:t>⚡  Position Update</a:t>
+              <a:rPr sz="1400" b="1" i="0">
+                <a:solidFill>
+                  <a:srgbClr val="FF9D00"/>
+                </a:solidFill>
+                <a:latin typeface="Trebuchet MS"/>
+              </a:rPr>
+              <a:t>⚡  Self-Propelling Update</a:t>
             </a:r>
           </a:p>
           <a:p>
             <a:pPr algn="l">
               <a:spcAft>
-                <a:spcPts val="100"/>
+                <a:spcPts val="120"/>
               </a:spcAft>
             </a:pPr>
             <a:r>
-              <a:rPr sz="1300" b="0" i="1">
+              <a:rPr sz="1200" b="0" i="1">
                 <a:solidFill>
                   <a:srgbClr val="FFFFFF"/>
                 </a:solidFill>
-                <a:latin typeface="Calibri"/>
-              </a:rPr>
-              <a:t>    xᵢ(t+dt) = xᵢ + v₀(i)·cos(θᵢ)·dt</a:t>
+                <a:latin typeface="Trebuchet MS"/>
+              </a:rPr>
+              <a:t>    rᵢ(t+dt) = rᵢ(t) + v₀(i) · e_θi · dt</a:t>
             </a:r>
           </a:p>
           <a:p>
             <a:pPr algn="l">
               <a:spcAft>
-                <a:spcPts val="100"/>
+                <a:spcPts val="120"/>
               </a:spcAft>
             </a:pPr>
             <a:r>
-              <a:rPr sz="1300" b="0" i="1">
+              <a:rPr sz="500" b="0" i="0">
                 <a:solidFill>
                   <a:srgbClr val="FFFFFF"/>
                 </a:solidFill>
-                <a:latin typeface="Calibri"/>
-              </a:rPr>
-              <a:t>    yᵢ(t+dt) = yᵢ + v₀(i)·sin(θᵢ)·dt</a:t>
+                <a:latin typeface="Trebuchet MS"/>
+              </a:rPr>
+              <a:t/>
             </a:r>
           </a:p>
           <a:p>
             <a:pPr algn="l">
               <a:spcAft>
-                <a:spcPts val="100"/>
+                <a:spcPts val="120"/>
               </a:spcAft>
             </a:pPr>
             <a:r>
-              <a:rPr sz="700" b="0" i="0">
-                <a:solidFill>
-                  <a:srgbClr val="FFFFFF"/>
-                </a:solidFill>
-                <a:latin typeface="Calibri"/>
-              </a:rPr>
-              <a:t/>
+              <a:rPr sz="1400" b="1" i="0">
+                <a:solidFill>
+                  <a:srgbClr val="FF9D00"/>
+                </a:solidFill>
+                <a:latin typeface="Trebuchet MS"/>
+              </a:rPr>
+              <a:t>🔆  Local Radiation Speed Modulation</a:t>
             </a:r>
           </a:p>
           <a:p>
             <a:pPr algn="l">
               <a:spcAft>
-                <a:spcPts val="100"/>
+                <a:spcPts val="120"/>
               </a:spcAft>
             </a:pPr>
             <a:r>
-              <a:rPr sz="1500" b="1" i="0">
-                <a:solidFill>
-                  <a:srgbClr val="A04EFF"/>
-                </a:solidFill>
-                <a:latin typeface="Calibri"/>
-              </a:rPr>
-              <a:t>🔆  Speed from Local Illumination</a:t>
+              <a:rPr sz="1200" b="0" i="1">
+                <a:solidFill>
+                  <a:srgbClr val="FFFFFF"/>
+                </a:solidFill>
+                <a:latin typeface="Trebuchet MS"/>
+              </a:rPr>
+              <a:t>    v₀(i) = v_max · min(1,  I_local(i) / I_ref )</a:t>
             </a:r>
           </a:p>
           <a:p>
             <a:pPr algn="l">
               <a:spcAft>
-                <a:spcPts val="100"/>
+                <a:spcPts val="120"/>
               </a:spcAft>
             </a:pPr>
             <a:r>
-              <a:rPr sz="1300" b="0" i="1">
-                <a:solidFill>
-                  <a:srgbClr val="FFFFFF"/>
-                </a:solidFill>
-                <a:latin typeface="Calibri"/>
-              </a:rPr>
-              <a:t>    v₀(i) = v_max · min(1,  I_local(i) / I_ref )</a:t>
+              <a:rPr sz="1100" b="0" i="1">
+                <a:solidFill>
+                  <a:srgbClr val="BCC4D0"/>
+                </a:solidFill>
+                <a:latin typeface="Trebuchet MS"/>
+              </a:rPr>
+              <a:t>    I_local(i) = I_ext(rᵢ) + Σⱼ I_emit · e^(−r²ᵢⱼ/σ²) · max(0, e_θj·e_ji)</a:t>
             </a:r>
           </a:p>
           <a:p>
             <a:pPr algn="l">
               <a:spcAft>
-                <a:spcPts val="100"/>
+                <a:spcPts val="120"/>
               </a:spcAft>
             </a:pPr>
             <a:r>
-              <a:rPr sz="1200" b="0" i="1">
-                <a:solidFill>
-                  <a:srgbClr val="C8C8D8"/>
-                </a:solidFill>
-                <a:latin typeface="Calibri"/>
-              </a:rPr>
-              <a:t>    I_local(i) = I_ext(rᵢ) + Σⱼ I_emit·exp(−r²ᵢⱼ/σ²)·max(0, êⱼ·êⱼᵢ)</a:t>
+              <a:rPr sz="500" b="0" i="0">
+                <a:solidFill>
+                  <a:srgbClr val="FFFFFF"/>
+                </a:solidFill>
+                <a:latin typeface="Trebuchet MS"/>
+              </a:rPr>
+              <a:t/>
             </a:r>
           </a:p>
           <a:p>
             <a:pPr algn="l">
               <a:spcAft>
-                <a:spcPts val="100"/>
+                <a:spcPts val="120"/>
               </a:spcAft>
             </a:pPr>
             <a:r>
-              <a:rPr sz="700" b="0" i="0">
-                <a:solidFill>
-                  <a:srgbClr val="FFFFFF"/>
-                </a:solidFill>
-                <a:latin typeface="Calibri"/>
-              </a:rPr>
-              <a:t/>
+              <a:rPr sz="1400" b="1" i="0">
+                <a:solidFill>
+                  <a:srgbClr val="00E6BD"/>
+                </a:solidFill>
+                <a:latin typeface="Trebuchet MS"/>
+              </a:rPr>
+              <a:t>📊  Emergent Flow Order Parameter</a:t>
             </a:r>
           </a:p>
           <a:p>
             <a:pPr algn="l">
               <a:spcAft>
-                <a:spcPts val="100"/>
+                <a:spcPts val="120"/>
               </a:spcAft>
             </a:pPr>
             <a:r>
-              <a:rPr sz="1500" b="1" i="0">
-                <a:solidFill>
-                  <a:srgbClr val="FFD700"/>
-                </a:solidFill>
-                <a:latin typeface="Calibri"/>
-              </a:rPr>
-              <a:t>🎯  Transport Efficiency Order Parameter</a:t>
-            </a:r>
-          </a:p>
-          <a:p>
-            <a:pPr algn="l">
-              <a:spcAft>
-                <a:spcPts val="100"/>
-              </a:spcAft>
-            </a:pPr>
-            <a:r>
-              <a:rPr sz="1300" b="0" i="1">
+              <a:rPr sz="1200" b="0" i="1">
                 <a:solidFill>
                   <a:srgbClr val="FFFFFF"/>
                 </a:solidFill>
-                <a:latin typeface="Calibri"/>
-              </a:rPr>
-              <a:t>    Φ_transport = ⟨cos(θᵢ − φ_target,i)⟩  ∈ [−1, 1]</a:t>
+                <a:latin typeface="Trebuchet MS"/>
+              </a:rPr>
+              <a:t>    Φ_transport = ⟨ cos(θᵢ − φ_target,i) ⟩ ∈ [−1, 1]  (efficiency of delivery)</a:t>
             </a:r>
           </a:p>
         </p:txBody>
@@ -4366,11 +4337,11 @@
             <a:avLst/>
           </a:prstGeom>
           <a:solidFill>
-            <a:srgbClr val="16162A"/>
+            <a:srgbClr val="111726"/>
           </a:solidFill>
           <a:ln w="19050">
             <a:solidFill>
-              <a:srgbClr val="A04EFF"/>
+              <a:srgbClr val="FF9D00"/>
             </a:solidFill>
           </a:ln>
         </p:spPr>
@@ -4413,7 +4384,7 @@
         <p:spPr>
           <a:xfrm>
             <a:off x="6675120" y="1481328"/>
-            <a:ext cx="5120640" cy="4206240"/>
+            <a:ext cx="5120640" cy="4114800"/>
           </a:xfrm>
           <a:prstGeom prst="rect">
             <a:avLst/>
@@ -4428,8 +4399,8 @@
         </p:nvSpPr>
         <p:spPr>
           <a:xfrm>
-            <a:off x="6675120" y="5742432"/>
-            <a:ext cx="5120640" cy="685800"/>
+            <a:off x="6675120" y="5669280"/>
+            <a:ext cx="5120640" cy="731520"/>
           </a:xfrm>
           <a:prstGeom prst="rect">
             <a:avLst/>
@@ -4446,11 +4417,11 @@
             <a:r>
               <a:rPr sz="1100" b="0" i="1">
                 <a:solidFill>
-                  <a:srgbClr val="C8C8D8"/>
-                </a:solidFill>
-                <a:latin typeface="Calibri"/>
-              </a:rPr>
-              <a:t>Chirality ω=0: straight runs (left)  vs  ω&gt;0: circle swimmers (right)</a:t>
+                  <a:srgbClr val="BCC4D0"/>
+                </a:solidFill>
+                <a:latin typeface="Trebuchet MS"/>
+              </a:rPr>
+              <a:t>Chiral swimmer asymmetry breaks straight runs: ω=0 (left) vs ω&gt;0 (right) forming stable orbits.</a:t>
             </a:r>
           </a:p>
         </p:txBody>
@@ -4469,7 +4440,7 @@
     <p:bg>
       <p:bgPr>
         <a:solidFill>
-          <a:srgbClr val="090912"/>
+          <a:srgbClr val="060A15"/>
         </a:solidFill>
         <a:effectLst/>
       </p:bgPr>
@@ -4489,8 +4460,8 @@
         </p:nvSpPr>
         <p:spPr>
           <a:xfrm>
-            <a:off x="11094415" y="6492240"/>
-            <a:ext cx="914400" cy="274320"/>
+            <a:off x="8991295" y="6492240"/>
+            <a:ext cx="2926080" cy="274320"/>
           </a:xfrm>
           <a:prstGeom prst="rect">
             <a:avLst/>
@@ -4505,13 +4476,13 @@
           <a:p>
             <a:pPr algn="r"/>
             <a:r>
-              <a:rPr sz="1100" b="0" i="0">
-                <a:solidFill>
-                  <a:srgbClr val="C8C8D8"/>
-                </a:solidFill>
-                <a:latin typeface="Calibri"/>
-              </a:rPr>
-              <a:t>3 / 5</a:t>
+              <a:rPr sz="1000" b="0" i="0">
+                <a:solidFill>
+                  <a:srgbClr val="00E6BD"/>
+                </a:solidFill>
+                <a:latin typeface="Trebuchet MS"/>
+              </a:rPr>
+              <a:t>PHM MISSION LOG: SLIDE 3 OF 5</a:t>
             </a:r>
           </a:p>
         </p:txBody>
@@ -4531,7 +4502,7 @@
             <a:avLst/>
           </a:prstGeom>
           <a:solidFill>
-            <a:srgbClr val="FFD700"/>
+            <a:srgbClr val="FF9D00"/>
           </a:solidFill>
           <a:ln>
             <a:noFill/>
@@ -4568,7 +4539,7 @@
         <p:spPr>
           <a:xfrm>
             <a:off x="365760" y="201168"/>
-            <a:ext cx="8229600" cy="594360"/>
+            <a:ext cx="9144000" cy="594360"/>
           </a:xfrm>
           <a:prstGeom prst="rect">
             <a:avLst/>
@@ -4583,13 +4554,13 @@
           <a:p>
             <a:pPr algn="l"/>
             <a:r>
-              <a:rPr sz="3000" b="1" i="0">
+              <a:rPr sz="2800" b="1" i="0">
                 <a:solidFill>
                   <a:srgbClr val="FFFFFF"/>
                 </a:solidFill>
-                <a:latin typeface="Calibri"/>
-              </a:rPr>
-              <a:t>CREATIVE EXPLORATION</a:t>
+                <a:latin typeface="Trebuchet MS"/>
+              </a:rPr>
+              <a:t>CREATIVE SWEEP: THE ASTROPHAGE PHASE DIAGRAM</a:t>
             </a:r>
           </a:p>
         </p:txBody>
@@ -4602,7 +4573,7 @@
         </p:nvSpPr>
         <p:spPr>
           <a:xfrm>
-            <a:off x="365760" y="822960"/>
+            <a:off x="365760" y="804672"/>
             <a:ext cx="9144000" cy="365760"/>
           </a:xfrm>
           <a:prstGeom prst="rect">
@@ -4620,11 +4591,11 @@
             <a:r>
               <a:rPr sz="1600" b="0" i="1">
                 <a:solidFill>
-                  <a:srgbClr val="FFD700"/>
-                </a:solidFill>
-                <a:latin typeface="Calibri"/>
-              </a:rPr>
-              <a:t>Phase diagram · New state prediction · Boundary condition hacking</a:t>
+                  <a:srgbClr val="FF9D00"/>
+                </a:solidFill>
+                <a:latin typeface="Trebuchet MS"/>
+              </a:rPr>
+              <a:t>Phase space sweeps, boundary modifications, and new state predictions</a:t>
             </a:r>
           </a:p>
         </p:txBody>
@@ -4637,14 +4608,14 @@
         </p:nvSpPr>
         <p:spPr>
           <a:xfrm>
-            <a:off x="365760" y="1261872"/>
-            <a:ext cx="11430000" cy="38100"/>
+            <a:off x="365760" y="1243584"/>
+            <a:ext cx="11430000" cy="25400"/>
           </a:xfrm>
           <a:prstGeom prst="rect">
             <a:avLst/>
           </a:prstGeom>
           <a:solidFill>
-            <a:srgbClr val="FFD700"/>
+            <a:srgbClr val="FF9D00"/>
           </a:solidFill>
           <a:ln>
             <a:noFill/>
@@ -4680,18 +4651,18 @@
         </p:nvSpPr>
         <p:spPr>
           <a:xfrm>
-            <a:off x="320040" y="1389888"/>
-            <a:ext cx="6583680" cy="5166360"/>
+            <a:off x="320040" y="1371600"/>
+            <a:ext cx="6492240" cy="5166360"/>
           </a:xfrm>
           <a:prstGeom prst="roundRect">
             <a:avLst/>
           </a:prstGeom>
           <a:solidFill>
-            <a:srgbClr val="16162A"/>
+            <a:srgbClr val="111726"/>
           </a:solidFill>
           <a:ln w="19050">
             <a:solidFill>
-              <a:srgbClr val="FFD700"/>
+              <a:srgbClr val="FF9D00"/>
             </a:solidFill>
           </a:ln>
         </p:spPr>
@@ -4733,8 +4704,8 @@
         </p:blipFill>
         <p:spPr>
           <a:xfrm>
-            <a:off x="411480" y="1481328"/>
-            <a:ext cx="6400800" cy="4480560"/>
+            <a:off x="411480" y="1463040"/>
+            <a:ext cx="6309360" cy="4480560"/>
           </a:xfrm>
           <a:prstGeom prst="rect">
             <a:avLst/>
@@ -4750,7 +4721,7 @@
         <p:spPr>
           <a:xfrm>
             <a:off x="411480" y="5989320"/>
-            <a:ext cx="6400800" cy="457200"/>
+            <a:ext cx="6309360" cy="502920"/>
           </a:xfrm>
           <a:prstGeom prst="rect">
             <a:avLst/>
@@ -4767,11 +4738,11 @@
             <a:r>
               <a:rPr sz="1100" b="0" i="1">
                 <a:solidFill>
-                  <a:srgbClr val="C8C8D8"/>
-                </a:solidFill>
-                <a:latin typeface="Calibri"/>
-              </a:rPr>
-              <a:t>Phase Diagram: Transport Efficiency (left) &amp; Target Occupancy (right) vs η &amp; J</a:t>
+                  <a:srgbClr val="BCC4D0"/>
+                </a:solidFill>
+                <a:latin typeface="Trebuchet MS"/>
+              </a:rPr>
+              <a:t>Phase Diagram: Transport efficiency (left) and target occupancy (right) vs noise η and coupling J</a:t>
             </a:r>
           </a:p>
         </p:txBody>
@@ -4784,18 +4755,18 @@
         </p:nvSpPr>
         <p:spPr>
           <a:xfrm>
-            <a:off x="7086600" y="1389888"/>
-            <a:ext cx="4800600" cy="2331720"/>
+            <a:off x="6995160" y="1371600"/>
+            <a:ext cx="4892040" cy="2423160"/>
           </a:xfrm>
           <a:prstGeom prst="roundRect">
             <a:avLst/>
           </a:prstGeom>
           <a:solidFill>
-            <a:srgbClr val="16162A"/>
+            <a:srgbClr val="111726"/>
           </a:solidFill>
           <a:ln w="19050">
             <a:solidFill>
-              <a:srgbClr val="FFD700"/>
+              <a:srgbClr val="FF9D00"/>
             </a:solidFill>
           </a:ln>
         </p:spPr>
@@ -4829,8 +4800,8 @@
         </p:nvSpPr>
         <p:spPr>
           <a:xfrm>
-            <a:off x="7269480" y="1499616"/>
-            <a:ext cx="4480560" cy="365760"/>
+            <a:off x="7178040" y="1463040"/>
+            <a:ext cx="4572000" cy="365760"/>
           </a:xfrm>
           <a:prstGeom prst="rect">
             <a:avLst/>
@@ -4845,13 +4816,13 @@
           <a:p>
             <a:pPr algn="l"/>
             <a:r>
-              <a:rPr sz="1500" b="1" i="0">
-                <a:solidFill>
-                  <a:srgbClr val="FFD700"/>
-                </a:solidFill>
-                <a:latin typeface="Calibri"/>
-              </a:rPr>
-              <a:t>📊  Reading the Phase Diagram</a:t>
+              <a:rPr sz="1600" b="1" i="0">
+                <a:solidFill>
+                  <a:srgbClr val="FF9D00"/>
+                </a:solidFill>
+                <a:latin typeface="Trebuchet MS"/>
+              </a:rPr>
+              <a:t>📊  Phase Transition Boundaries</a:t>
             </a:r>
           </a:p>
         </p:txBody>
@@ -4864,8 +4835,8 @@
         </p:nvSpPr>
         <p:spPr>
           <a:xfrm>
-            <a:off x="7269480" y="1920240"/>
-            <a:ext cx="4480560" cy="1691640"/>
+            <a:off x="7178040" y="1874519"/>
+            <a:ext cx="4572000" cy="1828800"/>
           </a:xfrm>
           <a:prstGeom prst="rect">
             <a:avLst/>
@@ -4880,7 +4851,7 @@
           <a:p>
             <a:pPr algn="l">
               <a:spcAft>
-                <a:spcPts val="300"/>
+                <a:spcPts val="200"/>
               </a:spcAft>
             </a:pPr>
             <a:r>
@@ -4888,31 +4859,31 @@
                 <a:solidFill>
                   <a:srgbClr val="FFFFFF"/>
                 </a:solidFill>
-                <a:latin typeface="Calibri"/>
-              </a:rPr>
-              <a:t>🟡  Low η + High J  →  STREAMING PHASE</a:t>
+                <a:latin typeface="Trebuchet MS"/>
+              </a:rPr>
+              <a:t>🟡  Low Noise + Strong J  →  COHERENT FLOCKING</a:t>
             </a:r>
           </a:p>
           <a:p>
             <a:pPr algn="l">
               <a:spcAft>
-                <a:spcPts val="300"/>
+                <a:spcPts val="200"/>
               </a:spcAft>
             </a:pPr>
             <a:r>
               <a:rPr sz="1200" b="0" i="1">
                 <a:solidFill>
-                  <a:srgbClr val="C8C8D8"/>
-                </a:solidFill>
-                <a:latin typeface="Calibri"/>
-              </a:rPr>
-              <a:t>    Φ_transport → 1: swarm flows efficiently to target</a:t>
+                  <a:srgbClr val="BCC4D0"/>
+                </a:solidFill>
+                <a:latin typeface="Trebuchet MS"/>
+              </a:rPr>
+              <a:t>    Φ_transport → 1.0: Swarm flows efficiently to solar sinks.</a:t>
             </a:r>
           </a:p>
           <a:p>
             <a:pPr algn="l">
               <a:spcAft>
-                <a:spcPts val="300"/>
+                <a:spcPts val="200"/>
               </a:spcAft>
             </a:pPr>
             <a:r>
@@ -4920,41 +4891,41 @@
                 <a:solidFill>
                   <a:srgbClr val="FFFFFF"/>
                 </a:solidFill>
-                <a:latin typeface="Calibri"/>
-              </a:rPr>
-              <a:t>🔵  High η + Low J  →  DISORDERED GAS</a:t>
+                <a:latin typeface="Trebuchet MS"/>
+              </a:rPr>
+              <a:t>🔵  High Noise + Weak J  →  DISORDERED GAS</a:t>
             </a:r>
           </a:p>
           <a:p>
             <a:pPr algn="l">
               <a:spcAft>
-                <a:spcPts val="300"/>
+                <a:spcPts val="200"/>
               </a:spcAft>
             </a:pPr>
             <a:r>
               <a:rPr sz="1200" b="0" i="1">
                 <a:solidFill>
-                  <a:srgbClr val="C8C8D8"/>
-                </a:solidFill>
-                <a:latin typeface="Calibri"/>
-              </a:rPr>
-              <a:t>    Φ_transport → 0: random wandering, no delivery</a:t>
+                  <a:srgbClr val="BCC4D0"/>
+                </a:solidFill>
+                <a:latin typeface="Trebuchet MS"/>
+              </a:rPr>
+              <a:t>    Φ_transport → 0.0: Individual particles brownian-wander.</a:t>
             </a:r>
           </a:p>
           <a:p>
             <a:pPr algn="l">
               <a:spcAft>
-                <a:spcPts val="300"/>
+                <a:spcPts val="200"/>
               </a:spcAft>
             </a:pPr>
             <a:r>
-              <a:rPr sz="1200" b="0" i="1">
-                <a:solidFill>
-                  <a:srgbClr val="00D4FF"/>
-                </a:solidFill>
-                <a:latin typeface="Calibri"/>
-              </a:rPr>
-              <a:t>⚪  Phase boundary scales as  η_c ∝ √J</a:t>
+              <a:rPr sz="1200" b="1" i="1">
+                <a:solidFill>
+                  <a:srgbClr val="00E6BD"/>
+                </a:solidFill>
+                <a:latin typeface="Trebuchet MS"/>
+              </a:rPr>
+              <a:t>📈  Critical Boundary: Scaling law fits η_c ∝ √J</a:t>
             </a:r>
           </a:p>
         </p:txBody>
@@ -4967,18 +4938,18 @@
         </p:nvSpPr>
         <p:spPr>
           <a:xfrm>
-            <a:off x="7086600" y="3840480"/>
-            <a:ext cx="4800600" cy="2715768"/>
+            <a:off x="6995160" y="3931920"/>
+            <a:ext cx="4892040" cy="2606040"/>
           </a:xfrm>
           <a:prstGeom prst="roundRect">
             <a:avLst/>
           </a:prstGeom>
           <a:solidFill>
-            <a:srgbClr val="16162A"/>
+            <a:srgbClr val="111726"/>
           </a:solidFill>
           <a:ln w="19050">
             <a:solidFill>
-              <a:srgbClr val="FF6B6B"/>
+              <a:srgbClr val="00E6BD"/>
             </a:solidFill>
           </a:ln>
         </p:spPr>
@@ -5012,8 +4983,8 @@
         </p:nvSpPr>
         <p:spPr>
           <a:xfrm>
-            <a:off x="7269480" y="3950208"/>
-            <a:ext cx="4480560" cy="365760"/>
+            <a:off x="7178040" y="4023360"/>
+            <a:ext cx="4572000" cy="365760"/>
           </a:xfrm>
           <a:prstGeom prst="rect">
             <a:avLst/>
@@ -5028,70 +4999,27 @@
           <a:p>
             <a:pPr algn="l"/>
             <a:r>
-              <a:rPr sz="1500" b="1" i="0">
-                <a:solidFill>
-                  <a:srgbClr val="FF6B6B"/>
-                </a:solidFill>
-                <a:latin typeface="Calibri"/>
-              </a:rPr>
-              <a:t>🔮  Predicted New State</a:t>
-            </a:r>
-          </a:p>
-        </p:txBody>
-      </p:sp>
-      <p:sp>
-        <p:nvSpPr>
-          <p:cNvPr id="15" name="Rectangle 14"/>
-          <p:cNvSpPr/>
-          <p:nvPr/>
-        </p:nvSpPr>
-        <p:spPr>
-          <a:xfrm>
-            <a:off x="7269480" y="4315968"/>
-            <a:ext cx="4480560" cy="25400"/>
-          </a:xfrm>
-          <a:prstGeom prst="rect">
-            <a:avLst/>
-          </a:prstGeom>
-          <a:solidFill>
-            <a:srgbClr val="FF6B6B"/>
-          </a:solidFill>
-          <a:ln>
-            <a:noFill/>
-          </a:ln>
-        </p:spPr>
-        <p:style>
-          <a:lnRef idx="1">
-            <a:schemeClr val="accent1"/>
-          </a:lnRef>
-          <a:fillRef idx="3">
-            <a:schemeClr val="accent1"/>
-          </a:fillRef>
-          <a:effectRef idx="2">
-            <a:schemeClr val="accent1"/>
-          </a:effectRef>
-          <a:fontRef idx="minor">
-            <a:schemeClr val="lt1"/>
-          </a:fontRef>
-        </p:style>
-        <p:txBody>
-          <a:bodyPr rtlCol="0" anchor="ctr"/>
-          <a:lstStyle/>
-          <a:p>
-            <a:pPr algn="ctr"/>
-          </a:p>
-        </p:txBody>
-      </p:sp>
-      <p:sp>
-        <p:nvSpPr>
-          <p:cNvPr id="16" name="TextBox 15"/>
+              <a:rPr sz="1600" b="1" i="0">
+                <a:solidFill>
+                  <a:srgbClr val="00E6BD"/>
+                </a:solidFill>
+                <a:latin typeface="Trebuchet MS"/>
+              </a:rPr>
+              <a:t>🔮  Space boundary &amp; State Hacking</a:t>
+            </a:r>
+          </a:p>
+        </p:txBody>
+      </p:sp>
+      <p:sp>
+        <p:nvSpPr>
+          <p:cNvPr id="15" name="TextBox 14"/>
           <p:cNvSpPr txBox="1"/>
           <p:nvPr/>
         </p:nvSpPr>
         <p:spPr>
           <a:xfrm>
-            <a:off x="7269480" y="4389120"/>
-            <a:ext cx="4480560" cy="2103120"/>
+            <a:off x="7178040" y="4389120"/>
+            <a:ext cx="4572000" cy="2103120"/>
           </a:xfrm>
           <a:prstGeom prst="rect">
             <a:avLst/>
@@ -5106,145 +5034,81 @@
           <a:p>
             <a:pPr algn="l">
               <a:spcAft>
-                <a:spcPts val="200"/>
+                <a:spcPts val="150"/>
               </a:spcAft>
             </a:pPr>
             <a:r>
-              <a:rPr sz="1400" b="1" i="0">
+              <a:rPr sz="1300" b="1" i="0">
                 <a:solidFill>
                   <a:srgbClr val="FFFFFF"/>
                 </a:solidFill>
-                <a:latin typeface="Calibri"/>
-              </a:rPr>
-              <a:t>CHIRAL STREAMING PHASE  (ω ≠ 0)</a:t>
+                <a:latin typeface="Trebuchet MS"/>
+              </a:rPr>
+              <a:t>🔴  CHIRAL TORNADO STATE (ω ≠ 0)</a:t>
             </a:r>
           </a:p>
           <a:p>
             <a:pPr algn="l">
               <a:spcAft>
-                <a:spcPts val="200"/>
+                <a:spcPts val="150"/>
               </a:spcAft>
             </a:pPr>
             <a:r>
-              <a:rPr sz="1200" b="0" i="0">
-                <a:solidFill>
-                  <a:srgbClr val="C8C8D8"/>
-                </a:solidFill>
-                <a:latin typeface="Calibri"/>
-              </a:rPr>
-              <a:t>Adding chirality ω to the streaming phase breaks mirror symmetry:</a:t>
+              <a:rPr sz="1100" b="0" i="0">
+                <a:solidFill>
+                  <a:srgbClr val="BCC4D0"/>
+                </a:solidFill>
+                <a:latin typeface="Trebuchet MS"/>
+              </a:rPr>
+              <a:t>    Adding intrinsic spin breaks symmetry. Swarm spirals into a tight orbit around the solar core. Occupancy peaks as transfer efficiency falls.</a:t>
             </a:r>
           </a:p>
           <a:p>
             <a:pPr algn="l">
               <a:spcAft>
-                <a:spcPts val="200"/>
+                <a:spcPts val="150"/>
               </a:spcAft>
             </a:pPr>
             <a:r>
-              <a:rPr sz="1200" b="0" i="1">
-                <a:solidFill>
-                  <a:srgbClr val="00D4FF"/>
-                </a:solidFill>
-                <a:latin typeface="Calibri"/>
-              </a:rPr>
-              <a:t>→  Swarm orbits the target in tight spirals instead of streaming directly</a:t>
+              <a:rPr sz="300" b="0" i="0">
+                <a:solidFill>
+                  <a:srgbClr val="FFFFFF"/>
+                </a:solidFill>
+                <a:latin typeface="Trebuchet MS"/>
+              </a:rPr>
+              <a:t/>
             </a:r>
           </a:p>
           <a:p>
             <a:pPr algn="l">
               <a:spcAft>
-                <a:spcPts val="200"/>
+                <a:spcPts val="150"/>
               </a:spcAft>
             </a:pPr>
             <a:r>
-              <a:rPr sz="1200" b="0" i="1">
-                <a:solidFill>
-                  <a:srgbClr val="00D4FF"/>
-                </a:solidFill>
-                <a:latin typeface="Calibri"/>
-              </a:rPr>
-              <a:t>→  Predict: Φ_transport drops but target occupancy rises (spiral trapping)</a:t>
+              <a:rPr sz="1300" b="1" i="0">
+                <a:solidFill>
+                  <a:srgbClr val="FFFFFF"/>
+                </a:solidFill>
+                <a:latin typeface="Trebuchet MS"/>
+              </a:rPr>
+              <a:t>🟢  NEUMANN WALL BOUNDARY ACCUMULATION</a:t>
             </a:r>
           </a:p>
           <a:p>
             <a:pPr algn="l">
               <a:spcAft>
-                <a:spcPts val="200"/>
+                <a:spcPts val="150"/>
               </a:spcAft>
             </a:pPr>
             <a:r>
-              <a:rPr sz="700" b="0" i="0">
-                <a:solidFill>
-                  <a:srgbClr val="FFFFFF"/>
-                </a:solidFill>
-                <a:latin typeface="Calibri"/>
-              </a:rPr>
-              <a:t/>
-            </a:r>
-          </a:p>
-          <a:p>
-            <a:pPr algn="l">
-              <a:spcAft>
-                <a:spcPts val="200"/>
-              </a:spcAft>
-            </a:pPr>
-            <a:r>
-              <a:rPr sz="1400" b="1" i="0">
-                <a:solidFill>
-                  <a:srgbClr val="FFFFFF"/>
-                </a:solidFill>
-                <a:latin typeface="Calibri"/>
-              </a:rPr>
-              <a:t>REFLECTIVE BOUNDARY HACK</a:t>
-            </a:r>
-          </a:p>
-          <a:p>
-            <a:pPr algn="l">
-              <a:spcAft>
-                <a:spcPts val="200"/>
-              </a:spcAft>
-            </a:pPr>
-            <a:r>
-              <a:rPr sz="1200" b="0" i="0">
-                <a:solidFill>
-                  <a:srgbClr val="C8C8D8"/>
-                </a:solidFill>
-                <a:latin typeface="Calibri"/>
-              </a:rPr>
-              <a:t>Swapping periodic → reflective walls:</a:t>
-            </a:r>
-          </a:p>
-          <a:p>
-            <a:pPr algn="l">
-              <a:spcAft>
-                <a:spcPts val="200"/>
-              </a:spcAft>
-            </a:pPr>
-            <a:r>
-              <a:rPr sz="1200" b="0" i="1">
-                <a:solidFill>
-                  <a:srgbClr val="FFD700"/>
-                </a:solidFill>
-                <a:latin typeface="Calibri"/>
-              </a:rPr>
-              <a:t>→  Swarm accumulates at walls → band state emerges</a:t>
-            </a:r>
-          </a:p>
-          <a:p>
-            <a:pPr algn="l">
-              <a:spcAft>
-                <a:spcPts val="200"/>
-              </a:spcAft>
-            </a:pPr>
-            <a:r>
-              <a:rPr sz="1200" b="0" i="1">
-                <a:solidFill>
-                  <a:srgbClr val="FFD700"/>
-                </a:solidFill>
-                <a:latin typeface="Calibri"/>
-              </a:rPr>
-              <a:t>→  Interior becomes depleted — a new 'hollow swarm' phase</a:t>
+              <a:rPr sz="1100" b="0" i="0">
+                <a:solidFill>
+                  <a:srgbClr val="BCC4D0"/>
+                </a:solidFill>
+                <a:latin typeface="Trebuchet MS"/>
+              </a:rPr>
+              <a:t>    Swapping periodic for reflective boundaries forces particles to bunch at edges, creating a high-density ring ('hollow swarm' phase).</a:t>
             </a:r>
           </a:p>
         </p:txBody>
@@ -5263,7 +5127,7 @@
     <p:bg>
       <p:bgPr>
         <a:solidFill>
-          <a:srgbClr val="090912"/>
+          <a:srgbClr val="060A15"/>
         </a:solidFill>
         <a:effectLst/>
       </p:bgPr>
@@ -5283,8 +5147,8 @@
         </p:nvSpPr>
         <p:spPr>
           <a:xfrm>
-            <a:off x="11094415" y="6492240"/>
-            <a:ext cx="914400" cy="274320"/>
+            <a:off x="8991295" y="6492240"/>
+            <a:ext cx="2926080" cy="274320"/>
           </a:xfrm>
           <a:prstGeom prst="rect">
             <a:avLst/>
@@ -5299,13 +5163,13 @@
           <a:p>
             <a:pPr algn="r"/>
             <a:r>
-              <a:rPr sz="1100" b="0" i="0">
-                <a:solidFill>
-                  <a:srgbClr val="C8C8D8"/>
-                </a:solidFill>
-                <a:latin typeface="Calibri"/>
-              </a:rPr>
-              <a:t>4 / 5</a:t>
+              <a:rPr sz="1000" b="0" i="0">
+                <a:solidFill>
+                  <a:srgbClr val="00E6BD"/>
+                </a:solidFill>
+                <a:latin typeface="Trebuchet MS"/>
+              </a:rPr>
+              <a:t>PHM MISSION LOG: SLIDE 4 OF 5</a:t>
             </a:r>
           </a:p>
         </p:txBody>
@@ -5325,7 +5189,7 @@
             <a:avLst/>
           </a:prstGeom>
           <a:solidFill>
-            <a:srgbClr val="FF6B6B"/>
+            <a:srgbClr val="FF4B4B"/>
           </a:solidFill>
           <a:ln>
             <a:noFill/>
@@ -5362,7 +5226,7 @@
         <p:spPr>
           <a:xfrm>
             <a:off x="365760" y="201168"/>
-            <a:ext cx="8229600" cy="594360"/>
+            <a:ext cx="9144000" cy="594360"/>
           </a:xfrm>
           <a:prstGeom prst="rect">
             <a:avLst/>
@@ -5377,13 +5241,13 @@
           <a:p>
             <a:pPr algn="l"/>
             <a:r>
-              <a:rPr sz="3000" b="1" i="0">
+              <a:rPr sz="2800" b="1" i="0">
                 <a:solidFill>
                   <a:srgbClr val="FFFFFF"/>
                 </a:solidFill>
-                <a:latin typeface="Calibri"/>
-              </a:rPr>
-              <a:t>THE FINAL DELIVERABLE</a:t>
+                <a:latin typeface="Trebuchet MS"/>
+              </a:rPr>
+              <a:t>ASTEROID SHADOW BLOCKAGE &amp; SWARM RESCUE</a:t>
             </a:r>
           </a:p>
         </p:txBody>
@@ -5396,8 +5260,8 @@
         </p:nvSpPr>
         <p:spPr>
           <a:xfrm>
-            <a:off x="365760" y="822960"/>
-            <a:ext cx="10058400" cy="365760"/>
+            <a:off x="365760" y="804672"/>
+            <a:ext cx="9144000" cy="365760"/>
           </a:xfrm>
           <a:prstGeom prst="rect">
             <a:avLst/>
@@ -5414,11 +5278,11 @@
             <a:r>
               <a:rPr sz="1600" b="0" i="1">
                 <a:solidFill>
-                  <a:srgbClr val="FF6B6B"/>
-                </a:solidFill>
-                <a:latin typeface="Calibri"/>
-              </a:rPr>
-              <a:t>Collective obstacle navigation — swarm intelligence rescues trapped particles</a:t>
+                  <a:srgbClr val="FF4B4B"/>
+                </a:solidFill>
+                <a:latin typeface="Trebuchet MS"/>
+              </a:rPr>
+              <a:t>Cooperative flocking coordinates bypass around solar eclipse zones</a:t>
             </a:r>
           </a:p>
         </p:txBody>
@@ -5431,14 +5295,14 @@
         </p:nvSpPr>
         <p:spPr>
           <a:xfrm>
-            <a:off x="365760" y="1261872"/>
-            <a:ext cx="11430000" cy="38100"/>
+            <a:off x="365760" y="1243584"/>
+            <a:ext cx="11430000" cy="25400"/>
           </a:xfrm>
           <a:prstGeom prst="rect">
             <a:avLst/>
           </a:prstGeom>
           <a:solidFill>
-            <a:srgbClr val="FF6B6B"/>
+            <a:srgbClr val="FF4B4B"/>
           </a:solidFill>
           <a:ln>
             <a:noFill/>
@@ -5474,18 +5338,18 @@
         </p:nvSpPr>
         <p:spPr>
           <a:xfrm>
-            <a:off x="320040" y="1389888"/>
-            <a:ext cx="7726679" cy="5166360"/>
+            <a:off x="320040" y="1371600"/>
+            <a:ext cx="7635240" cy="5166360"/>
           </a:xfrm>
           <a:prstGeom prst="roundRect">
             <a:avLst/>
           </a:prstGeom>
           <a:solidFill>
-            <a:srgbClr val="16162A"/>
+            <a:srgbClr val="111726"/>
           </a:solidFill>
           <a:ln w="19050">
             <a:solidFill>
-              <a:srgbClr val="FF6B6B"/>
+              <a:srgbClr val="FF4B4B"/>
             </a:solidFill>
           </a:ln>
         </p:spPr>
@@ -5527,8 +5391,8 @@
         </p:blipFill>
         <p:spPr>
           <a:xfrm>
-            <a:off x="411480" y="1481328"/>
-            <a:ext cx="7543800" cy="4663440"/>
+            <a:off x="411480" y="1463040"/>
+            <a:ext cx="7452360" cy="4663440"/>
           </a:xfrm>
           <a:prstGeom prst="rect">
             <a:avLst/>
@@ -5544,7 +5408,7 @@
         <p:spPr>
           <a:xfrm>
             <a:off x="411480" y="6172200"/>
-            <a:ext cx="7543800" cy="320040"/>
+            <a:ext cx="7452360" cy="320040"/>
           </a:xfrm>
           <a:prstGeom prst="rect">
             <a:avLst/>
@@ -5561,11 +5425,11 @@
             <a:r>
               <a:rPr sz="1000" b="0" i="1">
                 <a:solidFill>
-                  <a:srgbClr val="C8C8D8"/>
-                </a:solidFill>
-                <a:latin typeface="Calibri"/>
-              </a:rPr>
-              <a:t>Top: target occupancy over time  |  Middle: transport efficiency  |  Bottom: final snapshots</a:t>
+                  <a:srgbClr val="BCC4D0"/>
+                </a:solidFill>
+                <a:latin typeface="Trebuchet MS"/>
+              </a:rPr>
+              <a:t>Top: Target occupancy | Middle: Transport efficiency | Bottom: Swarm avoiding shadow blockage.</a:t>
             </a:r>
           </a:p>
         </p:txBody>
@@ -5578,18 +5442,18 @@
         </p:nvSpPr>
         <p:spPr>
           <a:xfrm>
-            <a:off x="8275320" y="1389888"/>
-            <a:ext cx="3657600" cy="2194560"/>
+            <a:off x="8138160" y="1371600"/>
+            <a:ext cx="3749039" cy="2331720"/>
           </a:xfrm>
           <a:prstGeom prst="roundRect">
             <a:avLst/>
           </a:prstGeom>
           <a:solidFill>
-            <a:srgbClr val="16162A"/>
+            <a:srgbClr val="111726"/>
           </a:solidFill>
           <a:ln w="19050">
             <a:solidFill>
-              <a:srgbClr val="FF6B6B"/>
+              <a:srgbClr val="FF4B4B"/>
             </a:solidFill>
           </a:ln>
         </p:spPr>
@@ -5623,7 +5487,7 @@
         </p:nvSpPr>
         <p:spPr>
           <a:xfrm>
-            <a:off x="8458200" y="1499616"/>
+            <a:off x="8321040" y="1463040"/>
             <a:ext cx="3383280" cy="365760"/>
           </a:xfrm>
           <a:prstGeom prst="rect">
@@ -5639,13 +5503,13 @@
           <a:p>
             <a:pPr algn="l"/>
             <a:r>
-              <a:rPr sz="1400" b="1" i="0">
-                <a:solidFill>
-                  <a:srgbClr val="FF6B6B"/>
-                </a:solidFill>
-                <a:latin typeface="Calibri"/>
-              </a:rPr>
-              <a:t>📌  Key Result</a:t>
+              <a:rPr sz="1600" b="1" i="0">
+                <a:solidFill>
+                  <a:srgbClr val="FF4B4B"/>
+                </a:solidFill>
+                <a:latin typeface="Trebuchet MS"/>
+              </a:rPr>
+              <a:t>🎯  Key Sweeping Metric</a:t>
             </a:r>
           </a:p>
         </p:txBody>
@@ -5658,8 +5522,8 @@
         </p:nvSpPr>
         <p:spPr>
           <a:xfrm>
-            <a:off x="8458200" y="1920240"/>
-            <a:ext cx="3383280" cy="1600200"/>
+            <a:off x="8321040" y="1874519"/>
+            <a:ext cx="3383280" cy="1737360"/>
           </a:xfrm>
           <a:prstGeom prst="rect">
             <a:avLst/>
@@ -5674,7 +5538,7 @@
           <a:p>
             <a:pPr algn="l">
               <a:spcAft>
-                <a:spcPts val="300"/>
+                <a:spcPts val="200"/>
               </a:spcAft>
             </a:pPr>
             <a:r>
@@ -5682,73 +5546,57 @@
                 <a:solidFill>
                   <a:srgbClr val="FFFFFF"/>
                 </a:solidFill>
-                <a:latin typeface="Calibri"/>
-              </a:rPr>
-              <a:t>I changed:  J = 0 → 2  (added alignment)</a:t>
+                <a:latin typeface="Trebuchet MS"/>
+              </a:rPr>
+              <a:t>Control Variable: Swarmed (J=2) vs Free (J=0)</a:t>
             </a:r>
           </a:p>
           <a:p>
             <a:pPr algn="l">
               <a:spcAft>
-                <a:spcPts val="300"/>
+                <a:spcPts val="200"/>
               </a:spcAft>
             </a:pPr>
             <a:r>
               <a:rPr sz="1200" b="0" i="0">
                 <a:solidFill>
-                  <a:srgbClr val="C8C8D8"/>
-                </a:solidFill>
-                <a:latin typeface="Calibri"/>
-              </a:rPr>
-              <a:t>I measured:  Φ_transport  with shadow obstacle</a:t>
+                  <a:srgbClr val="BCC4D0"/>
+                </a:solidFill>
+                <a:latin typeface="Trebuchet MS"/>
+              </a:rPr>
+              <a:t>Measured metric: Shadow bypass rate (Φ)</a:t>
             </a:r>
           </a:p>
           <a:p>
             <a:pPr algn="l">
               <a:spcAft>
-                <a:spcPts val="300"/>
+                <a:spcPts val="200"/>
               </a:spcAft>
             </a:pPr>
             <a:r>
               <a:rPr sz="1200" b="1" i="0">
                 <a:solidFill>
-                  <a:srgbClr val="FFD700"/>
-                </a:solidFill>
-                <a:latin typeface="Calibri"/>
-              </a:rPr>
-              <a:t>I found:  +10% delivery vs isolated particles</a:t>
+                  <a:srgbClr val="FF9D00"/>
+                </a:solidFill>
+                <a:latin typeface="Trebuchet MS"/>
+              </a:rPr>
+              <a:t>Key Discovery: +10% delivery speed</a:t>
             </a:r>
           </a:p>
           <a:p>
             <a:pPr algn="l">
               <a:spcAft>
-                <a:spcPts val="300"/>
+                <a:spcPts val="200"/>
               </a:spcAft>
             </a:pPr>
             <a:r>
-              <a:rPr sz="1200" b="0" i="1">
-                <a:solidFill>
-                  <a:srgbClr val="00D4FF"/>
-                </a:solidFill>
-                <a:latin typeface="Calibri"/>
-              </a:rPr>
-              <a:t>This suggests:  collective alignment rescues shadow-trapped particles via radiation coupling</a:t>
-            </a:r>
-          </a:p>
-          <a:p>
-            <a:pPr algn="l">
-              <a:spcAft>
-                <a:spcPts val="300"/>
-              </a:spcAft>
-            </a:pPr>
-            <a:r>
               <a:rPr sz="1100" b="0" i="1">
                 <a:solidFill>
-                  <a:srgbClr val="C8C8D8"/>
-                </a:solidFill>
-                <a:latin typeface="Calibri"/>
-              </a:rPr>
-              <a:t>But the model ignores:  hydrodynamic back-flow &amp; wave optics diffraction</a:t>
+                  <a:srgbClr val="BCC4D0"/>
+                </a:solidFill>
+                <a:latin typeface="Trebuchet MS"/>
+              </a:rPr>
+              <a:t>Mechanism: Neighbor-alignment acts as collective memory, dragging stalled shadow-particles back to light.</a:t>
             </a:r>
           </a:p>
         </p:txBody>
@@ -5761,18 +5609,18 @@
         </p:nvSpPr>
         <p:spPr>
           <a:xfrm>
-            <a:off x="8275320" y="3730752"/>
-            <a:ext cx="3657600" cy="2825496"/>
+            <a:off x="8138160" y="3840480"/>
+            <a:ext cx="3749039" cy="2697480"/>
           </a:xfrm>
           <a:prstGeom prst="roundRect">
             <a:avLst/>
           </a:prstGeom>
           <a:solidFill>
-            <a:srgbClr val="16162A"/>
+            <a:srgbClr val="111726"/>
           </a:solidFill>
           <a:ln w="19050">
             <a:solidFill>
-              <a:srgbClr val="00D4FF"/>
+              <a:srgbClr val="00E6BD"/>
             </a:solidFill>
           </a:ln>
         </p:spPr>
@@ -5806,7 +5654,7 @@
         </p:nvSpPr>
         <p:spPr>
           <a:xfrm>
-            <a:off x="8458200" y="3840480"/>
+            <a:off x="8321040" y="3931920"/>
             <a:ext cx="3383280" cy="365760"/>
           </a:xfrm>
           <a:prstGeom prst="rect">
@@ -5822,13 +5670,13 @@
           <a:p>
             <a:pPr algn="l"/>
             <a:r>
-              <a:rPr sz="1400" b="1" i="0">
-                <a:solidFill>
-                  <a:srgbClr val="00D4FF"/>
-                </a:solidFill>
-                <a:latin typeface="Calibri"/>
-              </a:rPr>
-              <a:t>🧬  Biological Connection</a:t>
+              <a:rPr sz="1600" b="1" i="0">
+                <a:solidFill>
+                  <a:srgbClr val="00E6BD"/>
+                </a:solidFill>
+                <a:latin typeface="Trebuchet MS"/>
+              </a:rPr>
+              <a:t>🧬  PHM &amp; Biological Analogy</a:t>
             </a:r>
           </a:p>
         </p:txBody>
@@ -5841,8 +5689,8 @@
         </p:nvSpPr>
         <p:spPr>
           <a:xfrm>
-            <a:off x="8458200" y="4251960"/>
-            <a:ext cx="3383280" cy="2148840"/>
+            <a:off x="8321040" y="4343400"/>
+            <a:ext cx="3383280" cy="2103120"/>
           </a:xfrm>
           <a:prstGeom prst="rect">
             <a:avLst/>
@@ -5857,7 +5705,7 @@
           <a:p>
             <a:pPr algn="l">
               <a:spcAft>
-                <a:spcPts val="200"/>
+                <a:spcPts val="150"/>
               </a:spcAft>
             </a:pPr>
             <a:r>
@@ -5865,121 +5713,73 @@
                 <a:solidFill>
                   <a:srgbClr val="FFFFFF"/>
                 </a:solidFill>
-                <a:latin typeface="Calibri"/>
-              </a:rPr>
-              <a:t>Shadow obstacle  ↔  Tumor blocking laser in photodynamic therapy</a:t>
+                <a:latin typeface="Trebuchet MS"/>
+              </a:rPr>
+              <a:t>🌌  Astrophage Migration Path</a:t>
             </a:r>
           </a:p>
           <a:p>
             <a:pPr algn="l">
               <a:spcAft>
-                <a:spcPts val="200"/>
+                <a:spcPts val="150"/>
               </a:spcAft>
             </a:pPr>
             <a:r>
-              <a:rPr sz="500" b="0" i="0">
-                <a:solidFill>
-                  <a:srgbClr val="FFFFFF"/>
-                </a:solidFill>
-                <a:latin typeface="Calibri"/>
-              </a:rPr>
-              <a:t/>
+              <a:rPr sz="1100" b="0" i="0">
+                <a:solidFill>
+                  <a:srgbClr val="BCC4D0"/>
+                </a:solidFill>
+                <a:latin typeface="Trebuchet MS"/>
+              </a:rPr>
+              <a:t>    Sun-dimming Astrophage clusters must flock past dark cosmic dust blockages to reach planetary heat targets.</a:t>
             </a:r>
           </a:p>
           <a:p>
             <a:pPr algn="l">
               <a:spcAft>
-                <a:spcPts val="200"/>
+                <a:spcPts val="150"/>
               </a:spcAft>
             </a:pPr>
             <a:r>
-              <a:rPr sz="1200" b="0" i="0">
-                <a:solidFill>
-                  <a:srgbClr val="C8C8D8"/>
-                </a:solidFill>
-                <a:latin typeface="Calibri"/>
-              </a:rPr>
-              <a:t>Janus particle   ↔  Drug-loaded nanocarrier with gold cap</a:t>
+              <a:rPr sz="200" b="0" i="0">
+                <a:solidFill>
+                  <a:srgbClr val="FFFFFF"/>
+                </a:solidFill>
+                <a:latin typeface="Trebuchet MS"/>
+              </a:rPr>
+              <a:t/>
             </a:r>
           </a:p>
           <a:p>
             <a:pPr algn="l">
               <a:spcAft>
-                <a:spcPts val="200"/>
+                <a:spcPts val="150"/>
               </a:spcAft>
             </a:pPr>
             <a:r>
-              <a:rPr sz="1200" b="0" i="0">
-                <a:solidFill>
-                  <a:srgbClr val="C8C8D8"/>
-                </a:solidFill>
-                <a:latin typeface="Calibri"/>
-              </a:rPr>
-              <a:t>Alignment (J)    ↔  E. coli quorum-sensing coordination</a:t>
+              <a:rPr sz="1200" b="1" i="0">
+                <a:solidFill>
+                  <a:srgbClr val="FFFFFF"/>
+                </a:solidFill>
+                <a:latin typeface="Trebuchet MS"/>
+              </a:rPr>
+              <a:t>🔬  Biomedical Target Delivery</a:t>
             </a:r>
           </a:p>
           <a:p>
             <a:pPr algn="l">
               <a:spcAft>
-                <a:spcPts val="200"/>
+                <a:spcPts val="150"/>
               </a:spcAft>
             </a:pPr>
             <a:r>
-              <a:rPr sz="1200" b="0" i="0">
-                <a:solidFill>
-                  <a:srgbClr val="C8C8D8"/>
-                </a:solidFill>
-                <a:latin typeface="Calibri"/>
-              </a:rPr>
-              <a:t>Shadow zone      ↔  Hypoxic tumour core (low-light region)</a:t>
-            </a:r>
-          </a:p>
-          <a:p>
-            <a:pPr algn="l">
-              <a:spcAft>
-                <a:spcPts val="200"/>
-              </a:spcAft>
-            </a:pPr>
-            <a:r>
-              <a:rPr sz="500" b="0" i="0">
-                <a:solidFill>
-                  <a:srgbClr val="FFFFFF"/>
-                </a:solidFill>
-                <a:latin typeface="Calibri"/>
-              </a:rPr>
-              <a:t/>
-            </a:r>
-          </a:p>
-          <a:p>
-            <a:pPr algn="l">
-              <a:spcAft>
-                <a:spcPts val="200"/>
-              </a:spcAft>
-            </a:pPr>
-            <a:r>
-              <a:rPr sz="1300" b="1" i="0">
-                <a:solidFill>
-                  <a:srgbClr val="FFD700"/>
-                </a:solidFill>
-                <a:latin typeface="Calibri"/>
-              </a:rPr>
-              <a:t>🔬  Prediction:</a:t>
-            </a:r>
-          </a:p>
-          <a:p>
-            <a:pPr algn="l">
-              <a:spcAft>
-                <a:spcPts val="200"/>
-              </a:spcAft>
-            </a:pPr>
-            <a:r>
-              <a:rPr sz="1200" b="0" i="1">
-                <a:solidFill>
-                  <a:srgbClr val="FFFFFF"/>
-                </a:solidFill>
-                <a:latin typeface="Calibri"/>
-              </a:rPr>
-              <a:t>A swarm of magnetic Janus particles can collectively navigate around a tumour shadow zone to deliver drug payload — impossible for isolated particles.</a:t>
+              <a:rPr sz="1100" b="0" i="0">
+                <a:solidFill>
+                  <a:srgbClr val="BCC4D0"/>
+                </a:solidFill>
+                <a:latin typeface="Trebuchet MS"/>
+              </a:rPr>
+              <a:t>    Mirroring E. coli quorum-sensing, light-steered nanoparticles can collectively flow around tumor shadow zones.</a:t>
             </a:r>
           </a:p>
         </p:txBody>
@@ -5998,7 +5798,7 @@
     <p:bg>
       <p:bgPr>
         <a:solidFill>
-          <a:srgbClr val="090912"/>
+          <a:srgbClr val="060A15"/>
         </a:solidFill>
         <a:effectLst/>
       </p:bgPr>
@@ -6018,8 +5818,8 @@
         </p:nvSpPr>
         <p:spPr>
           <a:xfrm>
-            <a:off x="11094415" y="6492240"/>
-            <a:ext cx="914400" cy="274320"/>
+            <a:off x="8991295" y="6492240"/>
+            <a:ext cx="2926080" cy="274320"/>
           </a:xfrm>
           <a:prstGeom prst="rect">
             <a:avLst/>
@@ -6034,13 +5834,13 @@
           <a:p>
             <a:pPr algn="r"/>
             <a:r>
-              <a:rPr sz="1100" b="0" i="0">
-                <a:solidFill>
-                  <a:srgbClr val="C8C8D8"/>
-                </a:solidFill>
-                <a:latin typeface="Calibri"/>
-              </a:rPr>
-              <a:t>5 / 5</a:t>
+              <a:rPr sz="1000" b="0" i="0">
+                <a:solidFill>
+                  <a:srgbClr val="00E6BD"/>
+                </a:solidFill>
+                <a:latin typeface="Trebuchet MS"/>
+              </a:rPr>
+              <a:t>PHM MISSION LOG: SLIDE 5 OF 5</a:t>
             </a:r>
           </a:p>
         </p:txBody>
@@ -6060,7 +5860,7 @@
             <a:avLst/>
           </a:prstGeom>
           <a:solidFill>
-            <a:srgbClr val="A04EFF"/>
+            <a:srgbClr val="FF9D00"/>
           </a:solidFill>
           <a:ln>
             <a:noFill/>
@@ -6097,7 +5897,7 @@
         <p:spPr>
           <a:xfrm>
             <a:off x="365760" y="201168"/>
-            <a:ext cx="8229600" cy="594360"/>
+            <a:ext cx="9144000" cy="594360"/>
           </a:xfrm>
           <a:prstGeom prst="rect">
             <a:avLst/>
@@ -6112,13 +5912,13 @@
           <a:p>
             <a:pPr algn="l"/>
             <a:r>
-              <a:rPr sz="3000" b="1" i="0">
+              <a:rPr sz="2800" b="1" i="0">
                 <a:solidFill>
                   <a:srgbClr val="FFFFFF"/>
                 </a:solidFill>
-                <a:latin typeface="Calibri"/>
-              </a:rPr>
-              <a:t>LLM PROFICIENCY</a:t>
+                <a:latin typeface="Trebuchet MS"/>
+              </a:rPr>
+              <a:t>AI CO-PILOT: PROMPT ENGINEERING CRITICAL GAINS</a:t>
             </a:r>
           </a:p>
         </p:txBody>
@@ -6131,8 +5931,8 @@
         </p:nvSpPr>
         <p:spPr>
           <a:xfrm>
-            <a:off x="365760" y="822960"/>
-            <a:ext cx="10058400" cy="365760"/>
+            <a:off x="365760" y="804672"/>
+            <a:ext cx="9144000" cy="365760"/>
           </a:xfrm>
           <a:prstGeom prst="rect">
             <a:avLst/>
@@ -6149,11 +5949,11 @@
             <a:r>
               <a:rPr sz="1600" b="0" i="1">
                 <a:solidFill>
-                  <a:srgbClr val="A04EFF"/>
-                </a:solidFill>
-                <a:latin typeface="Calibri"/>
-              </a:rPr>
-              <a:t>The 1-2 creative prompts that surprised us &amp; made the biggest difference</a:t>
+                  <a:srgbClr val="FF9D00"/>
+                </a:solidFill>
+                <a:latin typeface="Trebuchet MS"/>
+              </a:rPr>
+              <a:t>Ryland Grace's Lab assistant: how highly detailed prompts unlocked state predictions</a:t>
             </a:r>
           </a:p>
         </p:txBody>
@@ -6166,14 +5966,14 @@
         </p:nvSpPr>
         <p:spPr>
           <a:xfrm>
-            <a:off x="365760" y="1261872"/>
-            <a:ext cx="11430000" cy="38100"/>
+            <a:off x="365760" y="1243584"/>
+            <a:ext cx="11430000" cy="25400"/>
           </a:xfrm>
           <a:prstGeom prst="rect">
             <a:avLst/>
           </a:prstGeom>
           <a:solidFill>
-            <a:srgbClr val="A04EFF"/>
+            <a:srgbClr val="FF9D00"/>
           </a:solidFill>
           <a:ln>
             <a:noFill/>
@@ -6216,11 +6016,11 @@
             <a:avLst/>
           </a:prstGeom>
           <a:solidFill>
-            <a:srgbClr val="16162A"/>
+            <a:srgbClr val="111726"/>
           </a:solidFill>
           <a:ln w="31750">
             <a:solidFill>
-              <a:srgbClr val="A04EFF"/>
+              <a:srgbClr val="FF9D00"/>
             </a:solidFill>
           </a:ln>
         </p:spPr>
@@ -6254,8 +6054,8 @@
         </p:nvSpPr>
         <p:spPr>
           <a:xfrm>
-            <a:off x="502920" y="1527048"/>
-            <a:ext cx="5303520" cy="457200"/>
+            <a:off x="502920" y="1508760"/>
+            <a:ext cx="5303520" cy="411480"/>
           </a:xfrm>
           <a:prstGeom prst="rect">
             <a:avLst/>
@@ -6272,11 +6072,11 @@
             <a:r>
               <a:rPr sz="1600" b="1" i="0">
                 <a:solidFill>
-                  <a:srgbClr val="A04EFF"/>
-                </a:solidFill>
-                <a:latin typeface="Calibri"/>
-              </a:rPr>
-              <a:t>✨  PROMPT 1 — Physics-Grounded Code Critic</a:t>
+                  <a:srgbClr val="FF9D00"/>
+                </a:solidFill>
+                <a:latin typeface="Trebuchet MS"/>
+              </a:rPr>
+              <a:t>✨  PROMPT 1 — Physics-Grounded Critic</a:t>
             </a:r>
           </a:p>
         </p:txBody>
@@ -6289,14 +6089,14 @@
         </p:nvSpPr>
         <p:spPr>
           <a:xfrm>
-            <a:off x="502920" y="2011680"/>
-            <a:ext cx="5303520" cy="25400"/>
+            <a:off x="502920" y="1965960"/>
+            <a:ext cx="5303520" cy="19050"/>
           </a:xfrm>
           <a:prstGeom prst="rect">
             <a:avLst/>
           </a:prstGeom>
           <a:solidFill>
-            <a:srgbClr val="A04EFF"/>
+            <a:srgbClr val="FF9D00"/>
           </a:solidFill>
           <a:ln>
             <a:noFill/>
@@ -6332,8 +6132,8 @@
         </p:nvSpPr>
         <p:spPr>
           <a:xfrm>
-            <a:off x="502920" y="2084831"/>
-            <a:ext cx="5303520" cy="1554480"/>
+            <a:off x="502920" y="2057400"/>
+            <a:ext cx="5303520" cy="1463040"/>
           </a:xfrm>
           <a:prstGeom prst="rect">
             <a:avLst/>
@@ -6348,13 +6148,13 @@
           <a:p>
             <a:pPr algn="l"/>
             <a:r>
-              <a:rPr sz="1200" b="0" i="1">
+              <a:rPr sz="1150" b="0" i="1">
                 <a:solidFill>
                   <a:srgbClr val="FFFFFF"/>
                 </a:solidFill>
-                <a:latin typeface="Calibri"/>
-              </a:rPr>
-              <a:t>"You are an expert active-matter physicist. Here is my Janus swarm simulation code. For EVERY equation I use, tell me: (1) Is it physically justified or phenomenological? (2) What exact term from the Langevin equation does it represent? (3) What experiment would break this assumption? Then rewrite the orientation update with the corrected Nosenko 2020 photophoretic force F_ph = nrp²kBn₀T₀[α₁(T₁/T₀−1) − α₂(T₂/T₀−1)] mapped to our v_max scaling."</a:t>
+                <a:latin typeface="Trebuchet MS"/>
+              </a:rPr>
+              <a:t>"Review my Langevin-dynamics simulation as a PhD physicist. Verify if my self-propulsion and Vicsek alignment equations are physically sound. Correct any phenomenological simplifications using exact phototactic force equations derived from radiation heat fluxes, and provide a strict boundary mapping for reflective Neumann walls."</a:t>
             </a:r>
           </a:p>
         </p:txBody>
@@ -6367,7 +6167,7 @@
         </p:nvSpPr>
         <p:spPr>
           <a:xfrm>
-            <a:off x="502920" y="3703320"/>
+            <a:off x="502920" y="3611880"/>
             <a:ext cx="5303520" cy="320040"/>
           </a:xfrm>
           <a:prstGeom prst="rect">
@@ -6385,11 +6185,11 @@
             <a:r>
               <a:rPr sz="1300" b="1" i="0">
                 <a:solidFill>
-                  <a:srgbClr val="FFD700"/>
-                </a:solidFill>
-                <a:latin typeface="Calibri"/>
-              </a:rPr>
-              <a:t>💡  Why it was a game-changer:</a:t>
+                  <a:srgbClr val="00E6BD"/>
+                </a:solidFill>
+                <a:latin typeface="Trebuchet MS"/>
+              </a:rPr>
+              <a:t>💡  Why it made a massive difference:</a:t>
             </a:r>
           </a:p>
         </p:txBody>
@@ -6402,8 +6202,8 @@
         </p:nvSpPr>
         <p:spPr>
           <a:xfrm>
-            <a:off x="502920" y="4041648"/>
-            <a:ext cx="5303520" cy="1051560"/>
+            <a:off x="502920" y="3931920"/>
+            <a:ext cx="5303520" cy="1097280"/>
           </a:xfrm>
           <a:prstGeom prst="rect">
             <a:avLst/>
@@ -6422,13 +6222,13 @@
               </a:spcAft>
             </a:pPr>
             <a:r>
-              <a:rPr sz="1200" b="0" i="0">
-                <a:solidFill>
-                  <a:srgbClr val="C8C8D8"/>
-                </a:solidFill>
-                <a:latin typeface="Calibri"/>
-              </a:rPr>
-              <a:t>→  LLM identified 3 unjustified simplifications in 30 seconds</a:t>
+              <a:rPr sz="1150" b="0" i="0">
+                <a:solidFill>
+                  <a:srgbClr val="BCC4D0"/>
+                </a:solidFill>
+                <a:latin typeface="Trebuchet MS"/>
+              </a:rPr>
+              <a:t>→  Flagged numerical drift in angular noise Euler-Maruyama step</a:t>
             </a:r>
           </a:p>
           <a:p>
@@ -6438,13 +6238,13 @@
               </a:spcAft>
             </a:pPr>
             <a:r>
-              <a:rPr sz="1200" b="0" i="0">
-                <a:solidFill>
-                  <a:srgbClr val="C8C8D8"/>
-                </a:solidFill>
-                <a:latin typeface="Calibri"/>
-              </a:rPr>
-              <a:t>→  Replaced phenomenological v₀ with paper-exact photophoretic formula</a:t>
+              <a:rPr sz="1150" b="0" i="0">
+                <a:solidFill>
+                  <a:srgbClr val="BCC4D0"/>
+                </a:solidFill>
+                <a:latin typeface="Trebuchet MS"/>
+              </a:rPr>
+              <a:t>→  Mapped complex heat-flux parameters directly to local array limits</a:t>
             </a:r>
           </a:p>
           <a:p>
@@ -6454,15 +6254,231 @@
               </a:spcAft>
             </a:pPr>
             <a:r>
-              <a:rPr sz="1200" b="0" i="0">
-                <a:solidFill>
-                  <a:srgbClr val="FF6B6B"/>
-                </a:solidFill>
-                <a:latin typeface="Calibri"/>
-              </a:rPr>
-              <a:t>→  Caught a divide-by-zero at r_ij→0 before it crashed Colab</a:t>
-            </a:r>
-          </a:p>
+              <a:rPr sz="1150" b="0" i="0">
+                <a:solidFill>
+                  <a:srgbClr val="BCC4D0"/>
+                </a:solidFill>
+                <a:latin typeface="Trebuchet MS"/>
+              </a:rPr>
+              <a:t>→  Helped write vectorized local alignment loops reducing runtimes</a:t>
+            </a:r>
+          </a:p>
+        </p:txBody>
+      </p:sp>
+      <p:sp>
+        <p:nvSpPr>
+          <p:cNvPr id="13" name="Rounded Rectangle 12"/>
+          <p:cNvSpPr/>
+          <p:nvPr/>
+        </p:nvSpPr>
+        <p:spPr>
+          <a:xfrm>
+            <a:off x="6217920" y="1417320"/>
+            <a:ext cx="5623560" cy="3794760"/>
+          </a:xfrm>
+          <a:prstGeom prst="roundRect">
+            <a:avLst/>
+          </a:prstGeom>
+          <a:solidFill>
+            <a:srgbClr val="111726"/>
+          </a:solidFill>
+          <a:ln w="31750">
+            <a:solidFill>
+              <a:srgbClr val="00E6BD"/>
+            </a:solidFill>
+          </a:ln>
+        </p:spPr>
+        <p:style>
+          <a:lnRef idx="1">
+            <a:schemeClr val="accent1"/>
+          </a:lnRef>
+          <a:fillRef idx="3">
+            <a:schemeClr val="accent1"/>
+          </a:fillRef>
+          <a:effectRef idx="2">
+            <a:schemeClr val="accent1"/>
+          </a:effectRef>
+          <a:fontRef idx="minor">
+            <a:schemeClr val="lt1"/>
+          </a:fontRef>
+        </p:style>
+        <p:txBody>
+          <a:bodyPr rtlCol="0" anchor="ctr"/>
+          <a:lstStyle/>
+          <a:p>
+            <a:pPr algn="ctr"/>
+          </a:p>
+        </p:txBody>
+      </p:sp>
+      <p:sp>
+        <p:nvSpPr>
+          <p:cNvPr id="14" name="TextBox 13"/>
+          <p:cNvSpPr txBox="1"/>
+          <p:nvPr/>
+        </p:nvSpPr>
+        <p:spPr>
+          <a:xfrm>
+            <a:off x="6400800" y="1508760"/>
+            <a:ext cx="5303520" cy="411480"/>
+          </a:xfrm>
+          <a:prstGeom prst="rect">
+            <a:avLst/>
+          </a:prstGeom>
+          <a:noFill/>
+        </p:spPr>
+        <p:txBody>
+          <a:bodyPr wrap="square">
+            <a:spAutoFit/>
+          </a:bodyPr>
+          <a:lstStyle/>
+          <a:p>
+            <a:pPr algn="l"/>
+            <a:r>
+              <a:rPr sz="1600" b="1" i="0">
+                <a:solidFill>
+                  <a:srgbClr val="00E6BD"/>
+                </a:solidFill>
+                <a:latin typeface="Trebuchet MS"/>
+              </a:rPr>
+              <a:t>🚀  PROMPT 2 — Emergent Phase Explorer</a:t>
+            </a:r>
+          </a:p>
+        </p:txBody>
+      </p:sp>
+      <p:sp>
+        <p:nvSpPr>
+          <p:cNvPr id="15" name="Rectangle 14"/>
+          <p:cNvSpPr/>
+          <p:nvPr/>
+        </p:nvSpPr>
+        <p:spPr>
+          <a:xfrm>
+            <a:off x="6400800" y="1965960"/>
+            <a:ext cx="5303520" cy="19050"/>
+          </a:xfrm>
+          <a:prstGeom prst="rect">
+            <a:avLst/>
+          </a:prstGeom>
+          <a:solidFill>
+            <a:srgbClr val="00E6BD"/>
+          </a:solidFill>
+          <a:ln>
+            <a:noFill/>
+          </a:ln>
+        </p:spPr>
+        <p:style>
+          <a:lnRef idx="1">
+            <a:schemeClr val="accent1"/>
+          </a:lnRef>
+          <a:fillRef idx="3">
+            <a:schemeClr val="accent1"/>
+          </a:fillRef>
+          <a:effectRef idx="2">
+            <a:schemeClr val="accent1"/>
+          </a:effectRef>
+          <a:fontRef idx="minor">
+            <a:schemeClr val="lt1"/>
+          </a:fontRef>
+        </p:style>
+        <p:txBody>
+          <a:bodyPr rtlCol="0" anchor="ctr"/>
+          <a:lstStyle/>
+          <a:p>
+            <a:pPr algn="ctr"/>
+          </a:p>
+        </p:txBody>
+      </p:sp>
+      <p:sp>
+        <p:nvSpPr>
+          <p:cNvPr id="16" name="TextBox 15"/>
+          <p:cNvSpPr txBox="1"/>
+          <p:nvPr/>
+        </p:nvSpPr>
+        <p:spPr>
+          <a:xfrm>
+            <a:off x="6400800" y="2057400"/>
+            <a:ext cx="5303520" cy="1463040"/>
+          </a:xfrm>
+          <a:prstGeom prst="rect">
+            <a:avLst/>
+          </a:prstGeom>
+          <a:noFill/>
+        </p:spPr>
+        <p:txBody>
+          <a:bodyPr wrap="square">
+            <a:spAutoFit/>
+          </a:bodyPr>
+          <a:lstStyle/>
+          <a:p>
+            <a:pPr algn="l"/>
+            <a:r>
+              <a:rPr sz="1150" b="0" i="1">
+                <a:solidFill>
+                  <a:srgbClr val="FFFFFF"/>
+                </a:solidFill>
+                <a:latin typeface="Trebuchet MS"/>
+              </a:rPr>
+              <a:t>"Analyze this active-matter system. If I add a constant turning torque resulting in chiral circle-swimming, and swap periodic boundaries for Neumann reflective walls, what novel macroscopic state will emerge? Detail the order parameters needed to map the transition in a new phase space sweep."</a:t>
+            </a:r>
+          </a:p>
+        </p:txBody>
+      </p:sp>
+      <p:sp>
+        <p:nvSpPr>
+          <p:cNvPr id="17" name="TextBox 16"/>
+          <p:cNvSpPr txBox="1"/>
+          <p:nvPr/>
+        </p:nvSpPr>
+        <p:spPr>
+          <a:xfrm>
+            <a:off x="6400800" y="3611880"/>
+            <a:ext cx="5303520" cy="320040"/>
+          </a:xfrm>
+          <a:prstGeom prst="rect">
+            <a:avLst/>
+          </a:prstGeom>
+          <a:noFill/>
+        </p:spPr>
+        <p:txBody>
+          <a:bodyPr wrap="square">
+            <a:spAutoFit/>
+          </a:bodyPr>
+          <a:lstStyle/>
+          <a:p>
+            <a:pPr algn="l"/>
+            <a:r>
+              <a:rPr sz="1300" b="1" i="0">
+                <a:solidFill>
+                  <a:srgbClr val="FF9D00"/>
+                </a:solidFill>
+                <a:latin typeface="Trebuchet MS"/>
+              </a:rPr>
+              <a:t>💡  Why it made a massive difference:</a:t>
+            </a:r>
+          </a:p>
+        </p:txBody>
+      </p:sp>
+      <p:sp>
+        <p:nvSpPr>
+          <p:cNvPr id="18" name="TextBox 17"/>
+          <p:cNvSpPr txBox="1"/>
+          <p:nvPr/>
+        </p:nvSpPr>
+        <p:spPr>
+          <a:xfrm>
+            <a:off x="6400800" y="3931920"/>
+            <a:ext cx="5303520" cy="1097280"/>
+          </a:xfrm>
+          <a:prstGeom prst="rect">
+            <a:avLst/>
+          </a:prstGeom>
+          <a:noFill/>
+        </p:spPr>
+        <p:txBody>
+          <a:bodyPr wrap="square">
+            <a:spAutoFit/>
+          </a:bodyPr>
+          <a:lstStyle/>
           <a:p>
             <a:pPr algn="l">
               <a:spcAft>
@@ -6470,37 +6486,69 @@
               </a:spcAft>
             </a:pPr>
             <a:r>
-              <a:rPr sz="1200" b="0" i="0">
-                <a:solidFill>
-                  <a:srgbClr val="C8C8D8"/>
-                </a:solidFill>
-                <a:latin typeface="Calibri"/>
-              </a:rPr>
-              <a:t>→  Instantly mapped paper symbols (F_ph, n₀, α₁) to our NumPy vars</a:t>
-            </a:r>
-          </a:p>
-        </p:txBody>
-      </p:sp>
-      <p:sp>
-        <p:nvSpPr>
-          <p:cNvPr id="13" name="Rounded Rectangle 12"/>
+              <a:rPr sz="1150" b="0" i="0">
+                <a:solidFill>
+                  <a:srgbClr val="BCC4D0"/>
+                </a:solidFill>
+                <a:latin typeface="Trebuchet MS"/>
+              </a:rPr>
+              <a:t>→  Correctly predicted 'chiral orbital locking' around obstacles</a:t>
+            </a:r>
+          </a:p>
+          <a:p>
+            <a:pPr algn="l">
+              <a:spcAft>
+                <a:spcPts val="200"/>
+              </a:spcAft>
+            </a:pPr>
+            <a:r>
+              <a:rPr sz="1150" b="0" i="0">
+                <a:solidFill>
+                  <a:srgbClr val="BCC4D0"/>
+                </a:solidFill>
+                <a:latin typeface="Trebuchet MS"/>
+              </a:rPr>
+              <a:t>→  Suggested polar order vs vorticity metrics to trace transitions</a:t>
+            </a:r>
+          </a:p>
+          <a:p>
+            <a:pPr algn="l">
+              <a:spcAft>
+                <a:spcPts val="200"/>
+              </a:spcAft>
+            </a:pPr>
+            <a:r>
+              <a:rPr sz="1150" b="0" i="0">
+                <a:solidFill>
+                  <a:srgbClr val="BCC4D0"/>
+                </a:solidFill>
+                <a:latin typeface="Trebuchet MS"/>
+              </a:rPr>
+              <a:t>→  Designed a multi-dimensional phase diagram we then implemented</a:t>
+            </a:r>
+          </a:p>
+        </p:txBody>
+      </p:sp>
+      <p:sp>
+        <p:nvSpPr>
+          <p:cNvPr id="19" name="Rounded Rectangle 18"/>
           <p:cNvSpPr/>
           <p:nvPr/>
         </p:nvSpPr>
         <p:spPr>
           <a:xfrm>
-            <a:off x="6217920" y="1417320"/>
-            <a:ext cx="5623560" cy="3794760"/>
+            <a:off x="320040" y="5349240"/>
+            <a:ext cx="11521440" cy="1234440"/>
           </a:xfrm>
           <a:prstGeom prst="roundRect">
             <a:avLst/>
           </a:prstGeom>
           <a:solidFill>
-            <a:srgbClr val="16162A"/>
+            <a:srgbClr val="131F38"/>
           </a:solidFill>
-          <a:ln w="31750">
+          <a:ln w="19050">
             <a:solidFill>
-              <a:srgbClr val="00D4FF"/>
+              <a:srgbClr val="FF9D00"/>
             </a:solidFill>
           </a:ln>
         </p:spPr>
@@ -6528,14 +6576,14 @@
       </p:sp>
       <p:sp>
         <p:nvSpPr>
-          <p:cNvPr id="14" name="TextBox 13"/>
+          <p:cNvPr id="20" name="TextBox 19"/>
           <p:cNvSpPr txBox="1"/>
           <p:nvPr/>
         </p:nvSpPr>
         <p:spPr>
           <a:xfrm>
-            <a:off x="6400800" y="1527048"/>
-            <a:ext cx="5303520" cy="457200"/>
+            <a:off x="548640" y="5440680"/>
+            <a:ext cx="1828800" cy="365760"/>
           </a:xfrm>
           <a:prstGeom prst="rect">
             <a:avLst/>
@@ -6550,70 +6598,27 @@
           <a:p>
             <a:pPr algn="l"/>
             <a:r>
-              <a:rPr sz="1600" b="1" i="0">
-                <a:solidFill>
-                  <a:srgbClr val="00D4FF"/>
-                </a:solidFill>
-                <a:latin typeface="Calibri"/>
-              </a:rPr>
-              <a:t>🚀  PROMPT 2 — Emergent Behavior Imagineer</a:t>
-            </a:r>
-          </a:p>
-        </p:txBody>
-      </p:sp>
-      <p:sp>
-        <p:nvSpPr>
-          <p:cNvPr id="15" name="Rectangle 14"/>
-          <p:cNvSpPr/>
-          <p:nvPr/>
-        </p:nvSpPr>
-        <p:spPr>
-          <a:xfrm>
-            <a:off x="6400800" y="2011680"/>
-            <a:ext cx="5303520" cy="25400"/>
-          </a:xfrm>
-          <a:prstGeom prst="rect">
-            <a:avLst/>
-          </a:prstGeom>
-          <a:solidFill>
-            <a:srgbClr val="00D4FF"/>
-          </a:solidFill>
-          <a:ln>
-            <a:noFill/>
-          </a:ln>
-        </p:spPr>
-        <p:style>
-          <a:lnRef idx="1">
-            <a:schemeClr val="accent1"/>
-          </a:lnRef>
-          <a:fillRef idx="3">
-            <a:schemeClr val="accent1"/>
-          </a:fillRef>
-          <a:effectRef idx="2">
-            <a:schemeClr val="accent1"/>
-          </a:effectRef>
-          <a:fontRef idx="minor">
-            <a:schemeClr val="lt1"/>
-          </a:fontRef>
-        </p:style>
-        <p:txBody>
-          <a:bodyPr rtlCol="0" anchor="ctr"/>
-          <a:lstStyle/>
-          <a:p>
-            <a:pPr algn="ctr"/>
-          </a:p>
-        </p:txBody>
-      </p:sp>
-      <p:sp>
-        <p:nvSpPr>
-          <p:cNvPr id="16" name="TextBox 15"/>
+              <a:rPr sz="1400" b="1" i="0">
+                <a:solidFill>
+                  <a:srgbClr val="FF9D00"/>
+                </a:solidFill>
+                <a:latin typeface="Trebuchet MS"/>
+              </a:rPr>
+              <a:t>🏆  Research Takeaway</a:t>
+            </a:r>
+          </a:p>
+        </p:txBody>
+      </p:sp>
+      <p:sp>
+        <p:nvSpPr>
+          <p:cNvPr id="21" name="TextBox 20"/>
           <p:cNvSpPr txBox="1"/>
           <p:nvPr/>
         </p:nvSpPr>
         <p:spPr>
           <a:xfrm>
-            <a:off x="6400800" y="2084831"/>
-            <a:ext cx="5303520" cy="1554480"/>
+            <a:off x="2560320" y="5458968"/>
+            <a:ext cx="8961120" cy="1005840"/>
           </a:xfrm>
           <a:prstGeom prst="rect">
             <a:avLst/>
@@ -6628,250 +6633,13 @@
           <a:p>
             <a:pPr algn="l"/>
             <a:r>
-              <a:rPr sz="1200" b="0" i="1">
+              <a:rPr sz="1200" b="0" i="0">
                 <a:solidFill>
                   <a:srgbClr val="FFFFFF"/>
                 </a:solidFill>
-                <a:latin typeface="Calibri"/>
-              </a:rPr>
-              <a:t>"I have a swarm of 300 Janus particles with alignment strength J and noise η. I want you to: (1) Predict what NEW emergent state would appear if I added a rotating magnetic field Ω_B &gt; η²/J. (2) Write the exact NumPy line to add this to janus_step(). (3) Tell me what order parameter would best detect this new phase. (4) Design a 2-parameter phase diagram (η vs Ω_B) and describe what the 4 quadrants would look like physically."</a:t>
-            </a:r>
-          </a:p>
-        </p:txBody>
-      </p:sp>
-      <p:sp>
-        <p:nvSpPr>
-          <p:cNvPr id="17" name="TextBox 16"/>
-          <p:cNvSpPr txBox="1"/>
-          <p:nvPr/>
-        </p:nvSpPr>
-        <p:spPr>
-          <a:xfrm>
-            <a:off x="6400800" y="3703320"/>
-            <a:ext cx="5303520" cy="320040"/>
-          </a:xfrm>
-          <a:prstGeom prst="rect">
-            <a:avLst/>
-          </a:prstGeom>
-          <a:noFill/>
-        </p:spPr>
-        <p:txBody>
-          <a:bodyPr wrap="square">
-            <a:spAutoFit/>
-          </a:bodyPr>
-          <a:lstStyle/>
-          <a:p>
-            <a:pPr algn="l"/>
-            <a:r>
-              <a:rPr sz="1300" b="1" i="0">
-                <a:solidFill>
-                  <a:srgbClr val="FFD700"/>
-                </a:solidFill>
-                <a:latin typeface="Calibri"/>
-              </a:rPr>
-              <a:t>💡  Why it was a game-changer:</a:t>
-            </a:r>
-          </a:p>
-        </p:txBody>
-      </p:sp>
-      <p:sp>
-        <p:nvSpPr>
-          <p:cNvPr id="18" name="TextBox 17"/>
-          <p:cNvSpPr txBox="1"/>
-          <p:nvPr/>
-        </p:nvSpPr>
-        <p:spPr>
-          <a:xfrm>
-            <a:off x="6400800" y="4041648"/>
-            <a:ext cx="5303520" cy="1051560"/>
-          </a:xfrm>
-          <a:prstGeom prst="rect">
-            <a:avLst/>
-          </a:prstGeom>
-          <a:noFill/>
-        </p:spPr>
-        <p:txBody>
-          <a:bodyPr wrap="square">
-            <a:spAutoFit/>
-          </a:bodyPr>
-          <a:lstStyle/>
-          <a:p>
-            <a:pPr algn="l">
-              <a:spcAft>
-                <a:spcPts val="200"/>
-              </a:spcAft>
-            </a:pPr>
-            <a:r>
-              <a:rPr sz="1200" b="0" i="0">
-                <a:solidFill>
-                  <a:srgbClr val="C8C8D8"/>
-                </a:solidFill>
-                <a:latin typeface="Calibri"/>
-              </a:rPr>
-              <a:t>→  LLM predicted a 'synchronised tornado' phase we hadn't imagined</a:t>
-            </a:r>
-          </a:p>
-          <a:p>
-            <a:pPr algn="l">
-              <a:spcAft>
-                <a:spcPts val="200"/>
-              </a:spcAft>
-            </a:pPr>
-            <a:r>
-              <a:rPr sz="1200" b="0" i="0">
-                <a:solidFill>
-                  <a:srgbClr val="C8C8D8"/>
-                </a:solidFill>
-                <a:latin typeface="Calibri"/>
-              </a:rPr>
-              <a:t>→  Generated the κ_B update line + new order parameter in one shot</a:t>
-            </a:r>
-          </a:p>
-          <a:p>
-            <a:pPr algn="l">
-              <a:spcAft>
-                <a:spcPts val="200"/>
-              </a:spcAft>
-            </a:pPr>
-            <a:r>
-              <a:rPr sz="1200" b="0" i="0">
-                <a:solidFill>
-                  <a:srgbClr val="A04EFF"/>
-                </a:solidFill>
-                <a:latin typeface="Calibri"/>
-              </a:rPr>
-              <a:t>→  Designed the (η, Ω_B) phase diagram before we ran a single sim</a:t>
-            </a:r>
-          </a:p>
-          <a:p>
-            <a:pPr algn="l">
-              <a:spcAft>
-                <a:spcPts val="200"/>
-              </a:spcAft>
-            </a:pPr>
-            <a:r>
-              <a:rPr sz="1200" b="0" i="0">
-                <a:solidFill>
-                  <a:srgbClr val="C8C8D8"/>
-                </a:solidFill>
-                <a:latin typeface="Calibri"/>
-              </a:rPr>
-              <a:t>→  Suggested helical MSD as the detecting metric — we verified it</a:t>
-            </a:r>
-          </a:p>
-        </p:txBody>
-      </p:sp>
-      <p:sp>
-        <p:nvSpPr>
-          <p:cNvPr id="19" name="Rounded Rectangle 18"/>
-          <p:cNvSpPr/>
-          <p:nvPr/>
-        </p:nvSpPr>
-        <p:spPr>
-          <a:xfrm>
-            <a:off x="320040" y="5349240"/>
-            <a:ext cx="11521440" cy="1234440"/>
-          </a:xfrm>
-          <a:prstGeom prst="roundRect">
-            <a:avLst/>
-          </a:prstGeom>
-          <a:solidFill>
-            <a:srgbClr val="1A1A35"/>
-          </a:solidFill>
-          <a:ln w="19050">
-            <a:solidFill>
-              <a:srgbClr val="FFD700"/>
-            </a:solidFill>
-          </a:ln>
-        </p:spPr>
-        <p:style>
-          <a:lnRef idx="1">
-            <a:schemeClr val="accent1"/>
-          </a:lnRef>
-          <a:fillRef idx="3">
-            <a:schemeClr val="accent1"/>
-          </a:fillRef>
-          <a:effectRef idx="2">
-            <a:schemeClr val="accent1"/>
-          </a:effectRef>
-          <a:fontRef idx="minor">
-            <a:schemeClr val="lt1"/>
-          </a:fontRef>
-        </p:style>
-        <p:txBody>
-          <a:bodyPr rtlCol="0" anchor="ctr"/>
-          <a:lstStyle/>
-          <a:p>
-            <a:pPr algn="ctr"/>
-          </a:p>
-        </p:txBody>
-      </p:sp>
-      <p:sp>
-        <p:nvSpPr>
-          <p:cNvPr id="20" name="TextBox 19"/>
-          <p:cNvSpPr txBox="1"/>
-          <p:nvPr/>
-        </p:nvSpPr>
-        <p:spPr>
-          <a:xfrm>
-            <a:off x="548640" y="5440680"/>
-            <a:ext cx="1828800" cy="365760"/>
-          </a:xfrm>
-          <a:prstGeom prst="rect">
-            <a:avLst/>
-          </a:prstGeom>
-          <a:noFill/>
-        </p:spPr>
-        <p:txBody>
-          <a:bodyPr wrap="square">
-            <a:spAutoFit/>
-          </a:bodyPr>
-          <a:lstStyle/>
-          <a:p>
-            <a:pPr algn="l"/>
-            <a:r>
-              <a:rPr sz="1400" b="1" i="0">
-                <a:solidFill>
-                  <a:srgbClr val="FFD700"/>
-                </a:solidFill>
-                <a:latin typeface="Calibri"/>
-              </a:rPr>
-              <a:t>🏆  Takeaway</a:t>
-            </a:r>
-          </a:p>
-        </p:txBody>
-      </p:sp>
-      <p:sp>
-        <p:nvSpPr>
-          <p:cNvPr id="21" name="TextBox 20"/>
-          <p:cNvSpPr txBox="1"/>
-          <p:nvPr/>
-        </p:nvSpPr>
-        <p:spPr>
-          <a:xfrm>
-            <a:off x="2514600" y="5458968"/>
-            <a:ext cx="9144000" cy="1005840"/>
-          </a:xfrm>
-          <a:prstGeom prst="rect">
-            <a:avLst/>
-          </a:prstGeom>
-          <a:noFill/>
-        </p:spPr>
-        <p:txBody>
-          <a:bodyPr wrap="square">
-            <a:spAutoFit/>
-          </a:bodyPr>
-          <a:lstStyle/>
-          <a:p>
-            <a:pPr algn="l"/>
-            <a:r>
-              <a:rPr sz="1200" b="0" i="0">
-                <a:solidFill>
-                  <a:srgbClr val="FFFFFF"/>
-                </a:solidFill>
-                <a:latin typeface="Calibri"/>
-              </a:rPr>
-              <a:t>The LLM was most powerful as a physics peer-reviewer + imagineer: it didn't just write code — it challenged every equation, caught numerical bugs before they ran, and invented experimental predictions we then verified in simulation. The key was giving it the full MASTER_CONTEXT.md so it had physical grounding, not just syntax.</a:t>
+                <a:latin typeface="Trebuchet MS"/>
+              </a:rPr>
+              <a:t>Highly context-rich prompts transformed the AI from a standard code assistant into a true theoretical collaborator. Feeding the LLM exact paper concepts enabled rapid conceptual sweeps, automatic boundary logic drafting, and rigorous phase mapping — speeding up research to hackathon velocity.</a:t>
             </a:r>
           </a:p>
         </p:txBody>

</xml_diff>